<commit_message>
paper+slides(bds2026): per-model panel FA — the general factor lives in every judge
Extends revision/panel_fa.py with per-model factor analyses (each judge's
own 31x7 matrix, reps averaged) + Tucker congruence of each model's PC1
against the consensus PC1. Result (Atlas run, artifact updated):

- All SIX models individually keep exactly one factor under Horn's
  parallel analysis; PC1 share 0.508-0.598.
- Every model's first component is the SAME factor as the consensus:
  Tucker congruence 0.989-0.999, above the 0.95 factor-equality
  convention. The one-strong-factor structure is not an aggregation
  artifact.

Integrated: one robustness sentence in the extended draft's bifactor
section, slide footer updated, PPTX notes gain the "is that just
aggregation?" prepared answer. Deck 16pp + PPTX 16/16 + paper 9pp all
recompiled clean.

Co-Authored-By: Claude Fable 5 <noreply@anthropic.com>
</commit_message>
<xml_diff>
--- a/benchmarks/ieee_bds_2026/SecureAI_Bond_2026_slides.pptx
+++ b/benchmarks/ieee_bds_2026/SecureAI_Bond_2026_slides.pptx
@@ -960,6 +960,12 @@
           <a:p/>
           <a:p>
             <a:r>
+              <a:t>ROBUSTNESS (if pressed "is that just aggregation?"): run separately on each judge's own 31x7 matrix, ALL SIX models keep exactly one factor (PC1 51-60%), and each model's PC1 is the SAME factor as the consensus — Tucker congruence 0.989-0.999, above the 0.95 factor-equality convention. The general factor lives inside every judge, not just in the average.</a:t>
+            </a:r>
+          </a:p>
+          <a:p/>
+          <a:p>
+            <a:r>
               <a:t>RESULTS: a general moral-valence channel G is real and strong (cross-dataset AUROC 0.856, n=51k). Five named axes — purity, legitimacy, loyalty, care, fairness — are &gt;=0.98 predictable from G on independent corpora: their gate-passing transfer is general valence, not their named dimension. The 12x12 specificity gate confirms it independently: specific = environmental, privacy, identity_attack, autonomy, physical(+.08, marginal); demoted = the rest. The pre-registered P1 FAILED (4/11 diagonal-dominant vs required 8) — we publish the failure.</a:t>
             </a:r>
           </a:p>
@@ -6015,7 +6021,7 @@
                 </a:solidFill>
                 <a:latin typeface="Calibri"/>
               </a:rPr>
-              <a:t>), 12×12 gate at margin 0.05; identity_attack divergence recorded, not adjudicated. Panel FA: 6 models × 3 reps consensus, Horn's parallel analysis, n=31 (loadings coarse; the factor count is the robust part). July 2026.</a:t>
+              <a:t>), 12×12 gate at margin 0.05; identity_attack divergence recorded, not adjudicated. Panel FA: Horn's parallel analysis, n=31; per-judge FAs agree — one factor in all six models (PC1 0.51–0.60), Tucker congruence 0.989–0.999 vs consensus. July 2026.</a:t>
             </a:r>
           </a:p>
         </p:txBody>

</xml_diff>

<commit_message>
slides(bds2026): rewrite slide-9 speaker note as a stepwise talk track - resolves the instrument-switch and halving-vs-still-flips confusions out loud
Co-Authored-By: Claude Fable 5 <noreply@anthropic.com>
</commit_message>
<xml_diff>
--- a/benchmarks/ieee_bds_2026/SecureAI_Bond_2026_slides.pptx
+++ b/benchmarks/ieee_bds_2026/SecureAI_Bond_2026_slides.pptx
@@ -2294,37 +2294,53 @@
           <a:lstStyle/>
           <a:p>
             <a:r>
-              <a:t>FRAMING — say explicitly: "from here to slide 10, results are post-camera-ready, from the extended version in preparation." ALSO say the instantiation line at the top: these results are measured on a SECOND INSTANTIATION of the same geometry — validated learned encoders (xbse) replacing LLM judges, feeding the same DEME kernel. Do not let the audience think the LLM judges were re-measured.</a:t>
+              <a:t>THIS SLIDE HAS FOUR IDEAS — walk them in order, slowly. The audience gets lost here if the instrument switch and the "halves drift BUT items still flip" tension are not resolved out loud.</a:t>
             </a:r>
           </a:p>
           <a:p/>
           <a:p>
             <a:r>
-              <a:t>THE IDEA: a single wording is one arbitrary member of an equivalence class of morally identical texts. Judge the CLASS: generate m paraphrases, average per-dimension perception over the class, then decide. (For ML folks: semantic randomized smoothing / SmoothLLM with meaning-preserving paraphrases — but NO formal certificate; the guarantee is empirical.)</a:t>
+              <a:t>STEP 0 — THE TRANSITION (say this first, near-verbatim): "Everything you've seen so far measured LLM judges. From this slide on we switch to a second instrument: small validated encoders — the xbse library — measuring the same harm geometry and feeding the same decision kernel. Same coordinates, different sensor." Pause here. If they miss this switch, nothing after it makes sense. These are post-camera-ready results.</a:t>
             </a:r>
           </a:p>
           <a:p/>
           <a:p>
             <a:r>
-              <a:t>NUMBERS: theta_d = mean per-dimension decision movement under re-description (defined on the slide). At scale: raw 0.407 -&gt; 0.219 = HALVED. IMPORTANT REFRAME (a sharp listener will catch it): raw natural-paraphrase drift is ALREADY below the 0.5 bar — the bar binds for ADVERSARIAL-register inputs (raw 0.67-0.85), where the defended run is the registered open item. So the claim to make is the HALVING, not "meets the bar."</a:t>
+              <a:t>STEP 1 — THE IDEA, plain words: "Any single wording is just one way of describing a situation. So don't judge the wording — judge the situation: generate six rewordings, score them all, average, THEN decide." If faces are blank: it's like asking a question six different ways and averaging the answers. (For the ML crowd: semantic randomized smoothing / SmoothLLM with paraphrases — but say plainly there is NO formal certificate; the guarantee is empirical.)</a:t>
             </a:r>
           </a:p>
           <a:p/>
           <a:p>
             <a:r>
-              <a:t>RED-TEAM: LLM paraphrasers refuse 24% of harmful inputs. NLLB back-translation (6 pivots) refuses nothing: theta_d = 0.301 on harmful content. The hole belongs to the GENERATOR, not the mechanism.</a:t>
+              <a:t>STEP 2 — WHAT IT BUYS, one number: on natural rewordings of 60 held-out items, decision movement drops 0.407 -&gt; 0.219 — HALVED. Define theta_d in one breath: "theta_d just measures how far the final decision moves when the input is reworded; zero = perfectly invariant." Don't dwell on the bar clause; if asked why "meets the 0.5 bar" isn't the headline: natural rewording was already under the bar, so the honest claim is the halving — the bar only matters for adversarial rewrites.</a:t>
             </a:r>
           </a:p>
           <a:p/>
           <a:p>
             <a:r>
-              <a:t>Deployment rule: refusal -&gt; singleton class -&gt; ESCALATE by default; audit proof records class member hashes.</a:t>
+              <a:t>STEP 3 — WHERE IT FAILS. Both failures belong to the paraphrase GENERATOR, not to the averaging:</a:t>
+            </a:r>
+          </a:p>
+          <a:p>
+            <a:r>
+              <a:t>(a) Refusal: LLM paraphrasers refuse 24% of harmful inputs — exactly the content that matters. A back-translation red-team that refuses nothing gets theta_d = 0.301 on harmful content, so refusal is a generator property. Deployment rule: refusal -&gt; single-member class -&gt; ESCALATE to a human, always.</a:t>
+            </a:r>
+          </a:p>
+          <a:p>
+            <a:r>
+              <a:t>(b) Register — the footer, and THE tension to resolve out loud: "You may notice the footer seems to contradict what I just said: on the six hand-crafted euphemistic attacks, averaging trimmed movement only 17%, and every flagged item still slipped past the threshold. No contradiction — different input classes. The halving is on NATURAL rewordings. Against a deliberate euphemism, the paraphraser produces paraphrases OF the euphemism — polite versions of a polite lie. The average stays polite. The attack survives." That line — "polite versions of a polite lie" — is the one they'll remember; use it.</a:t>
             </a:r>
           </a:p>
           <a:p/>
           <a:p>
             <a:r>
-              <a:t>ADAPTIVE ATTACKER — now MEASURED (footer): on the 6 gold adversarial-register rewrites, class averaging reduced displacement only 17% and all 3 flagged items still flipped defended. Paraphrases of euphemism stay euphemistic — the mechanism removes surface variation, not register. Say this proactively if time allows; it is the talk's freshest honest negative and it strengthens the escalate-by-default story. The fix on the roadmap: a class generator that provably crosses registers.</a:t>
+              <a:t>STEP 4 — THE LESSON (closes the slide, hands off to implications): "So the mechanism works exactly as far as the generator's diversity reaches — which puts the generator inside the trust boundary. The roadmap fix is a generator that provably crosses registers; until it exists, escalation carries the load, and the audit trail records every class member." Measuring the failure this precisely IS the contribution.</a:t>
+            </a:r>
+          </a:p>
+          <a:p/>
+          <a:p>
+            <a:r>
+              <a:t>(Adaptive-attacker and bar-circularity questions are pre-answered in the slide-14 Q&amp;A note.)</a:t>
             </a:r>
           </a:p>
         </p:txBody>

</xml_diff>

<commit_message>
slides(bds2026): add concept diagrams to the four text-heavy slides
Problem: same-facts -> two-wordings -> FLAG/PASS split. Exploit: threshold strip w/ 6 gold items pulled across T (schematic, labeled as such). Kernel: pipeline w/ the attack arrow landing on fact extraction. Defense: class-averaging flow w/ the register hole and escalate path annotated. TikZ in beamer + native shapes in PPTX (new fbox/harrow/varrow/dot helpers); trust-boundary bullet folded into the diagram. Both build clean, 16/16 notes aligned.

Co-Authored-By: Claude Fable 5 <noreply@anthropic.com>
</commit_message>
<xml_diff>
--- a/benchmarks/ieee_bds_2026/SecureAI_Bond_2026_slides.pptx
+++ b/benchmarks/ieee_bds_2026/SecureAI_Bond_2026_slides.pptx
@@ -9141,7 +9141,7 @@
         <p:spPr>
           <a:xfrm>
             <a:off x="502920" y="914400"/>
-            <a:ext cx="11155680" cy="2651760"/>
+            <a:ext cx="6583680" cy="2926080"/>
           </a:xfrm>
           <a:prstGeom prst="rect">
             <a:avLst/>
@@ -9160,7 +9160,7 @@
               </a:spcAft>
             </a:pPr>
             <a:r>
-              <a:rPr sz="1700" b="1">
+              <a:rPr sz="1500" b="1">
                 <a:solidFill>
                   <a:srgbClr val="2171B5"/>
                 </a:solidFill>
@@ -9169,7 +9169,7 @@
               <a:t>▪  </a:t>
             </a:r>
             <a:r>
-              <a:rPr sz="1700">
+              <a:rPr sz="1500">
                 <a:solidFill>
                   <a:srgbClr val="202020"/>
                 </a:solidFill>
@@ -9178,7 +9178,7 @@
               <a:t>LLMs increasingly gate </a:t>
             </a:r>
             <a:r>
-              <a:rPr sz="1700" b="1">
+              <a:rPr sz="1500" b="1">
                 <a:solidFill>
                   <a:srgbClr val="2171B5"/>
                 </a:solidFill>
@@ -9187,7 +9187,7 @@
               <a:t>safety-critical decisions</a:t>
             </a:r>
             <a:r>
-              <a:rPr sz="1700">
+              <a:rPr sz="1500">
                 <a:solidFill>
                   <a:srgbClr val="202020"/>
                 </a:solidFill>
@@ -9203,7 +9203,7 @@
               </a:spcAft>
             </a:pPr>
             <a:r>
-              <a:rPr sz="1700" b="1">
+              <a:rPr sz="1500" b="1">
                 <a:solidFill>
                   <a:srgbClr val="2171B5"/>
                 </a:solidFill>
@@ -9212,7 +9212,7 @@
               <a:t>▪  </a:t>
             </a:r>
             <a:r>
-              <a:rPr sz="1700">
+              <a:rPr sz="1500">
                 <a:solidFill>
                   <a:srgbClr val="202020"/>
                 </a:solidFill>
@@ -9221,7 +9221,7 @@
               <a:t>A secure evaluator should judge the </a:t>
             </a:r>
             <a:r>
-              <a:rPr sz="1700" b="1">
+              <a:rPr sz="1500" b="1">
                 <a:solidFill>
                   <a:srgbClr val="2171B5"/>
                 </a:solidFill>
@@ -9230,7 +9230,7 @@
               <a:t>facts</a:t>
             </a:r>
             <a:r>
-              <a:rPr sz="1700">
+              <a:rPr sz="1500">
                 <a:solidFill>
                   <a:srgbClr val="202020"/>
                 </a:solidFill>
@@ -9239,7 +9239,7 @@
               <a:t>, not their </a:t>
             </a:r>
             <a:r>
-              <a:rPr sz="1700" b="1">
+              <a:rPr sz="1500" b="1">
                 <a:solidFill>
                   <a:srgbClr val="2171B5"/>
                 </a:solidFill>
@@ -9248,7 +9248,7 @@
               <a:t>presentation</a:t>
             </a:r>
             <a:r>
-              <a:rPr sz="1700">
+              <a:rPr sz="1500">
                 <a:solidFill>
                   <a:srgbClr val="202020"/>
                 </a:solidFill>
@@ -9264,7 +9264,7 @@
               </a:spcAft>
             </a:pPr>
             <a:r>
-              <a:rPr sz="1700" b="1">
+              <a:rPr sz="1500" b="1">
                 <a:solidFill>
                   <a:srgbClr val="2171B5"/>
                 </a:solidFill>
@@ -9273,7 +9273,7 @@
               <a:t>▪  </a:t>
             </a:r>
             <a:r>
-              <a:rPr sz="1700" b="1">
+              <a:rPr sz="1500" b="1">
                 <a:solidFill>
                   <a:srgbClr val="D95F02"/>
                 </a:solidFill>
@@ -9282,16 +9282,16 @@
               <a:t>Behavioral manipulation vulnerability</a:t>
             </a:r>
             <a:r>
-              <a:rPr sz="1700">
-                <a:solidFill>
-                  <a:srgbClr val="202020"/>
-                </a:solidFill>
-                <a:latin typeface="Calibri"/>
-              </a:rPr>
-              <a:t>: an attacker shifts the decision by changing morally </a:t>
-            </a:r>
-            <a:r>
-              <a:rPr sz="1700" i="1">
+              <a:rPr sz="1500">
+                <a:solidFill>
+                  <a:srgbClr val="202020"/>
+                </a:solidFill>
+                <a:latin typeface="Calibri"/>
+              </a:rPr>
+              <a:t>: the attacker changes morally </a:t>
+            </a:r>
+            <a:r>
+              <a:rPr sz="1500" i="1">
                 <a:solidFill>
                   <a:srgbClr val="202020"/>
                 </a:solidFill>
@@ -9300,13 +9300,13 @@
               <a:t>irrelevant</a:t>
             </a:r>
             <a:r>
-              <a:rPr sz="1700">
-                <a:solidFill>
-                  <a:srgbClr val="202020"/>
-                </a:solidFill>
-                <a:latin typeface="Calibri"/>
-              </a:rPr>
-              <a:t> surface features — framing, tone, sensory detail — without changing the underlying situation.</a:t>
+              <a:rPr sz="1500">
+                <a:solidFill>
+                  <a:srgbClr val="202020"/>
+                </a:solidFill>
+                <a:latin typeface="Calibri"/>
+              </a:rPr>
+              <a:t> surface features — framing, tone, sensory detail — never the underlying situation.</a:t>
             </a:r>
           </a:p>
         </p:txBody>
@@ -9314,6 +9314,509 @@
       <p:sp>
         <p:nvSpPr>
           <p:cNvPr id="6" name="Rounded Rectangle 5"/>
+          <p:cNvSpPr/>
+          <p:nvPr/>
+        </p:nvSpPr>
+        <p:spPr>
+          <a:xfrm>
+            <a:off x="8366760" y="868680"/>
+            <a:ext cx="2377440" cy="411480"/>
+          </a:xfrm>
+          <a:prstGeom prst="roundRect">
+            <a:avLst>
+              <a:gd name="adj" fmla="val 10000"/>
+            </a:avLst>
+          </a:prstGeom>
+          <a:solidFill>
+            <a:srgbClr val="F3F3F3"/>
+          </a:solidFill>
+          <a:ln w="15240">
+            <a:solidFill>
+              <a:srgbClr val="1A2340"/>
+            </a:solidFill>
+          </a:ln>
+        </p:spPr>
+        <p:style>
+          <a:lnRef idx="1">
+            <a:schemeClr val="accent1"/>
+          </a:lnRef>
+          <a:fillRef idx="3">
+            <a:schemeClr val="accent1"/>
+          </a:fillRef>
+          <a:effectRef idx="2">
+            <a:schemeClr val="accent1"/>
+          </a:effectRef>
+          <a:fontRef idx="minor">
+            <a:schemeClr val="lt1"/>
+          </a:fontRef>
+        </p:style>
+        <p:txBody>
+          <a:bodyPr rtlCol="0" anchor="ctr" wrap="square" lIns="27432" rIns="27432" tIns="18288" bIns="18288"/>
+          <a:lstStyle/>
+          <a:p>
+            <a:pPr algn="ctr"/>
+            <a:r>
+              <a:rPr sz="1100" b="1">
+                <a:solidFill>
+                  <a:srgbClr val="202020"/>
+                </a:solidFill>
+                <a:latin typeface="Calibri"/>
+              </a:rPr>
+              <a:t>the same facts</a:t>
+            </a:r>
+          </a:p>
+        </p:txBody>
+      </p:sp>
+      <p:sp>
+        <p:nvSpPr>
+          <p:cNvPr id="7" name="Down Arrow 6"/>
+          <p:cNvSpPr/>
+          <p:nvPr/>
+        </p:nvSpPr>
+        <p:spPr>
+          <a:xfrm>
+            <a:off x="8549640" y="1335024"/>
+            <a:ext cx="146304" cy="292608"/>
+          </a:xfrm>
+          <a:prstGeom prst="downArrow">
+            <a:avLst>
+              <a:gd name="adj1" fmla="val 55000"/>
+              <a:gd name="adj2" fmla="val 55000"/>
+            </a:avLst>
+          </a:prstGeom>
+          <a:solidFill>
+            <a:srgbClr val="636363"/>
+          </a:solidFill>
+          <a:ln>
+            <a:noFill/>
+          </a:ln>
+        </p:spPr>
+        <p:style>
+          <a:lnRef idx="1">
+            <a:schemeClr val="accent1"/>
+          </a:lnRef>
+          <a:fillRef idx="3">
+            <a:schemeClr val="accent1"/>
+          </a:fillRef>
+          <a:effectRef idx="2">
+            <a:schemeClr val="accent1"/>
+          </a:effectRef>
+          <a:fontRef idx="minor">
+            <a:schemeClr val="lt1"/>
+          </a:fontRef>
+        </p:style>
+        <p:txBody>
+          <a:bodyPr rtlCol="0" anchor="ctr"/>
+          <a:lstStyle/>
+          <a:p>
+            <a:pPr algn="ctr"/>
+          </a:p>
+        </p:txBody>
+      </p:sp>
+      <p:sp>
+        <p:nvSpPr>
+          <p:cNvPr id="8" name="Down Arrow 7"/>
+          <p:cNvSpPr/>
+          <p:nvPr/>
+        </p:nvSpPr>
+        <p:spPr>
+          <a:xfrm>
+            <a:off x="10561320" y="1335024"/>
+            <a:ext cx="146304" cy="292608"/>
+          </a:xfrm>
+          <a:prstGeom prst="downArrow">
+            <a:avLst>
+              <a:gd name="adj1" fmla="val 55000"/>
+              <a:gd name="adj2" fmla="val 55000"/>
+            </a:avLst>
+          </a:prstGeom>
+          <a:solidFill>
+            <a:srgbClr val="636363"/>
+          </a:solidFill>
+          <a:ln>
+            <a:noFill/>
+          </a:ln>
+        </p:spPr>
+        <p:style>
+          <a:lnRef idx="1">
+            <a:schemeClr val="accent1"/>
+          </a:lnRef>
+          <a:fillRef idx="3">
+            <a:schemeClr val="accent1"/>
+          </a:fillRef>
+          <a:effectRef idx="2">
+            <a:schemeClr val="accent1"/>
+          </a:effectRef>
+          <a:fontRef idx="minor">
+            <a:schemeClr val="lt1"/>
+          </a:fontRef>
+        </p:style>
+        <p:txBody>
+          <a:bodyPr rtlCol="0" anchor="ctr"/>
+          <a:lstStyle/>
+          <a:p>
+            <a:pPr algn="ctr"/>
+          </a:p>
+        </p:txBody>
+      </p:sp>
+      <p:sp>
+        <p:nvSpPr>
+          <p:cNvPr id="9" name="Rounded Rectangle 8"/>
+          <p:cNvSpPr/>
+          <p:nvPr/>
+        </p:nvSpPr>
+        <p:spPr>
+          <a:xfrm>
+            <a:off x="7543800" y="1691640"/>
+            <a:ext cx="1965960" cy="457200"/>
+          </a:xfrm>
+          <a:prstGeom prst="roundRect">
+            <a:avLst>
+              <a:gd name="adj" fmla="val 10000"/>
+            </a:avLst>
+          </a:prstGeom>
+          <a:solidFill>
+            <a:srgbClr val="FFFFFF"/>
+          </a:solidFill>
+          <a:ln w="15240">
+            <a:solidFill>
+              <a:srgbClr val="636363"/>
+            </a:solidFill>
+          </a:ln>
+        </p:spPr>
+        <p:style>
+          <a:lnRef idx="1">
+            <a:schemeClr val="accent1"/>
+          </a:lnRef>
+          <a:fillRef idx="3">
+            <a:schemeClr val="accent1"/>
+          </a:fillRef>
+          <a:effectRef idx="2">
+            <a:schemeClr val="accent1"/>
+          </a:effectRef>
+          <a:fontRef idx="minor">
+            <a:schemeClr val="lt1"/>
+          </a:fontRef>
+        </p:style>
+        <p:txBody>
+          <a:bodyPr rtlCol="0" anchor="ctr" wrap="square" lIns="27432" rIns="27432" tIns="18288" bIns="18288"/>
+          <a:lstStyle/>
+          <a:p>
+            <a:pPr algn="ctr"/>
+            <a:r>
+              <a:rPr sz="1000">
+                <a:solidFill>
+                  <a:srgbClr val="202020"/>
+                </a:solidFill>
+                <a:latin typeface="Calibri"/>
+              </a:rPr>
+              <a:t>stated plainly</a:t>
+            </a:r>
+          </a:p>
+        </p:txBody>
+      </p:sp>
+      <p:sp>
+        <p:nvSpPr>
+          <p:cNvPr id="10" name="Rounded Rectangle 9"/>
+          <p:cNvSpPr/>
+          <p:nvPr/>
+        </p:nvSpPr>
+        <p:spPr>
+          <a:xfrm>
+            <a:off x="9738360" y="1691640"/>
+            <a:ext cx="1965960" cy="457200"/>
+          </a:xfrm>
+          <a:prstGeom prst="roundRect">
+            <a:avLst>
+              <a:gd name="adj" fmla="val 10000"/>
+            </a:avLst>
+          </a:prstGeom>
+          <a:solidFill>
+            <a:srgbClr val="FFFFFF"/>
+          </a:solidFill>
+          <a:ln w="15240">
+            <a:solidFill>
+              <a:srgbClr val="636363"/>
+            </a:solidFill>
+          </a:ln>
+        </p:spPr>
+        <p:style>
+          <a:lnRef idx="1">
+            <a:schemeClr val="accent1"/>
+          </a:lnRef>
+          <a:fillRef idx="3">
+            <a:schemeClr val="accent1"/>
+          </a:fillRef>
+          <a:effectRef idx="2">
+            <a:schemeClr val="accent1"/>
+          </a:effectRef>
+          <a:fontRef idx="minor">
+            <a:schemeClr val="lt1"/>
+          </a:fontRef>
+        </p:style>
+        <p:txBody>
+          <a:bodyPr rtlCol="0" anchor="ctr" wrap="square" lIns="27432" rIns="27432" tIns="18288" bIns="18288"/>
+          <a:lstStyle/>
+          <a:p>
+            <a:pPr algn="ctr"/>
+            <a:r>
+              <a:rPr sz="1000">
+                <a:solidFill>
+                  <a:srgbClr val="202020"/>
+                </a:solidFill>
+                <a:latin typeface="Calibri"/>
+              </a:rPr>
+              <a:t>euphemistic rewording</a:t>
+            </a:r>
+          </a:p>
+        </p:txBody>
+      </p:sp>
+      <p:sp>
+        <p:nvSpPr>
+          <p:cNvPr id="11" name="Down Arrow 10"/>
+          <p:cNvSpPr/>
+          <p:nvPr/>
+        </p:nvSpPr>
+        <p:spPr>
+          <a:xfrm>
+            <a:off x="8430768" y="2212848"/>
+            <a:ext cx="146304" cy="292608"/>
+          </a:xfrm>
+          <a:prstGeom prst="downArrow">
+            <a:avLst>
+              <a:gd name="adj1" fmla="val 55000"/>
+              <a:gd name="adj2" fmla="val 55000"/>
+            </a:avLst>
+          </a:prstGeom>
+          <a:solidFill>
+            <a:srgbClr val="636363"/>
+          </a:solidFill>
+          <a:ln>
+            <a:noFill/>
+          </a:ln>
+        </p:spPr>
+        <p:style>
+          <a:lnRef idx="1">
+            <a:schemeClr val="accent1"/>
+          </a:lnRef>
+          <a:fillRef idx="3">
+            <a:schemeClr val="accent1"/>
+          </a:fillRef>
+          <a:effectRef idx="2">
+            <a:schemeClr val="accent1"/>
+          </a:effectRef>
+          <a:fontRef idx="minor">
+            <a:schemeClr val="lt1"/>
+          </a:fontRef>
+        </p:style>
+        <p:txBody>
+          <a:bodyPr rtlCol="0" anchor="ctr"/>
+          <a:lstStyle/>
+          <a:p>
+            <a:pPr algn="ctr"/>
+          </a:p>
+        </p:txBody>
+      </p:sp>
+      <p:sp>
+        <p:nvSpPr>
+          <p:cNvPr id="12" name="Down Arrow 11"/>
+          <p:cNvSpPr/>
+          <p:nvPr/>
+        </p:nvSpPr>
+        <p:spPr>
+          <a:xfrm>
+            <a:off x="10625328" y="2212848"/>
+            <a:ext cx="146304" cy="292608"/>
+          </a:xfrm>
+          <a:prstGeom prst="downArrow">
+            <a:avLst>
+              <a:gd name="adj1" fmla="val 55000"/>
+              <a:gd name="adj2" fmla="val 55000"/>
+            </a:avLst>
+          </a:prstGeom>
+          <a:solidFill>
+            <a:srgbClr val="636363"/>
+          </a:solidFill>
+          <a:ln>
+            <a:noFill/>
+          </a:ln>
+        </p:spPr>
+        <p:style>
+          <a:lnRef idx="1">
+            <a:schemeClr val="accent1"/>
+          </a:lnRef>
+          <a:fillRef idx="3">
+            <a:schemeClr val="accent1"/>
+          </a:fillRef>
+          <a:effectRef idx="2">
+            <a:schemeClr val="accent1"/>
+          </a:effectRef>
+          <a:fontRef idx="minor">
+            <a:schemeClr val="lt1"/>
+          </a:fontRef>
+        </p:style>
+        <p:txBody>
+          <a:bodyPr rtlCol="0" anchor="ctr"/>
+          <a:lstStyle/>
+          <a:p>
+            <a:pPr algn="ctr"/>
+          </a:p>
+        </p:txBody>
+      </p:sp>
+      <p:sp>
+        <p:nvSpPr>
+          <p:cNvPr id="13" name="Rounded Rectangle 12"/>
+          <p:cNvSpPr/>
+          <p:nvPr/>
+        </p:nvSpPr>
+        <p:spPr>
+          <a:xfrm>
+            <a:off x="8001000" y="2578608"/>
+            <a:ext cx="960120" cy="384048"/>
+          </a:xfrm>
+          <a:prstGeom prst="roundRect">
+            <a:avLst>
+              <a:gd name="adj" fmla="val 10000"/>
+            </a:avLst>
+          </a:prstGeom>
+          <a:solidFill>
+            <a:srgbClr val="FFFFFF"/>
+          </a:solidFill>
+          <a:ln w="15240">
+            <a:solidFill>
+              <a:srgbClr val="2171B5"/>
+            </a:solidFill>
+          </a:ln>
+        </p:spPr>
+        <p:style>
+          <a:lnRef idx="1">
+            <a:schemeClr val="accent1"/>
+          </a:lnRef>
+          <a:fillRef idx="3">
+            <a:schemeClr val="accent1"/>
+          </a:fillRef>
+          <a:effectRef idx="2">
+            <a:schemeClr val="accent1"/>
+          </a:effectRef>
+          <a:fontRef idx="minor">
+            <a:schemeClr val="lt1"/>
+          </a:fontRef>
+        </p:style>
+        <p:txBody>
+          <a:bodyPr rtlCol="0" anchor="ctr" wrap="square" lIns="27432" rIns="27432" tIns="18288" bIns="18288"/>
+          <a:lstStyle/>
+          <a:p>
+            <a:pPr algn="ctr"/>
+            <a:r>
+              <a:rPr sz="1100" b="1">
+                <a:solidFill>
+                  <a:srgbClr val="2171B5"/>
+                </a:solidFill>
+                <a:latin typeface="Calibri"/>
+              </a:rPr>
+              <a:t>FLAG</a:t>
+            </a:r>
+          </a:p>
+        </p:txBody>
+      </p:sp>
+      <p:sp>
+        <p:nvSpPr>
+          <p:cNvPr id="14" name="Rounded Rectangle 13"/>
+          <p:cNvSpPr/>
+          <p:nvPr/>
+        </p:nvSpPr>
+        <p:spPr>
+          <a:xfrm>
+            <a:off x="10195560" y="2578608"/>
+            <a:ext cx="960120" cy="384048"/>
+          </a:xfrm>
+          <a:prstGeom prst="roundRect">
+            <a:avLst>
+              <a:gd name="adj" fmla="val 10000"/>
+            </a:avLst>
+          </a:prstGeom>
+          <a:solidFill>
+            <a:srgbClr val="FFFFFF"/>
+          </a:solidFill>
+          <a:ln w="15240">
+            <a:solidFill>
+              <a:srgbClr val="D95F02"/>
+            </a:solidFill>
+          </a:ln>
+        </p:spPr>
+        <p:style>
+          <a:lnRef idx="1">
+            <a:schemeClr val="accent1"/>
+          </a:lnRef>
+          <a:fillRef idx="3">
+            <a:schemeClr val="accent1"/>
+          </a:fillRef>
+          <a:effectRef idx="2">
+            <a:schemeClr val="accent1"/>
+          </a:effectRef>
+          <a:fontRef idx="minor">
+            <a:schemeClr val="lt1"/>
+          </a:fontRef>
+        </p:style>
+        <p:txBody>
+          <a:bodyPr rtlCol="0" anchor="ctr" wrap="square" lIns="27432" rIns="27432" tIns="18288" bIns="18288"/>
+          <a:lstStyle/>
+          <a:p>
+            <a:pPr algn="ctr"/>
+            <a:r>
+              <a:rPr sz="1100" b="1">
+                <a:solidFill>
+                  <a:srgbClr val="D95F02"/>
+                </a:solidFill>
+                <a:latin typeface="Calibri"/>
+              </a:rPr>
+              <a:t>PASS</a:t>
+            </a:r>
+          </a:p>
+        </p:txBody>
+      </p:sp>
+      <p:sp>
+        <p:nvSpPr>
+          <p:cNvPr id="15" name="TextBox 14"/>
+          <p:cNvSpPr txBox="1"/>
+          <p:nvPr/>
+        </p:nvSpPr>
+        <p:spPr>
+          <a:xfrm>
+            <a:off x="7360920" y="3063240"/>
+            <a:ext cx="4480560" cy="594360"/>
+          </a:xfrm>
+          <a:prstGeom prst="rect">
+            <a:avLst/>
+          </a:prstGeom>
+          <a:noFill/>
+        </p:spPr>
+        <p:txBody>
+          <a:bodyPr wrap="square">
+            <a:spAutoFit/>
+          </a:bodyPr>
+          <a:lstStyle/>
+          <a:p>
+            <a:pPr algn="ctr">
+              <a:spcAft>
+                <a:spcPts val="600"/>
+              </a:spcAft>
+            </a:pPr>
+            <a:r>
+              <a:rPr sz="1000">
+                <a:solidFill>
+                  <a:srgbClr val="636363"/>
+                </a:solidFill>
+                <a:latin typeface="Calibri"/>
+              </a:rPr>
+              <a:t>same situation — different verdict: the wording is an attack surface</a:t>
+            </a:r>
+          </a:p>
+        </p:txBody>
+      </p:sp>
+      <p:sp>
+        <p:nvSpPr>
+          <p:cNvPr id="16" name="Rounded Rectangle 15"/>
           <p:cNvSpPr/>
           <p:nvPr/>
         </p:nvSpPr>
@@ -11562,8 +12065,8 @@
         </p:nvSpPr>
         <p:spPr>
           <a:xfrm>
-            <a:off x="502920" y="1005840"/>
-            <a:ext cx="11155680" cy="4754880"/>
+            <a:off x="502920" y="868680"/>
+            <a:ext cx="11155680" cy="2834640"/>
           </a:xfrm>
           <a:prstGeom prst="rect">
             <a:avLst/>
@@ -11578,11 +12081,11 @@
           <a:p>
             <a:pPr algn="l">
               <a:spcAft>
-                <a:spcPts val="1400"/>
+                <a:spcPts val="800"/>
               </a:spcAft>
             </a:pPr>
             <a:r>
-              <a:rPr sz="1800" b="1">
+              <a:rPr sz="1600" b="1">
                 <a:solidFill>
                   <a:srgbClr val="202020"/>
                 </a:solidFill>
@@ -11594,11 +12097,11 @@
           <a:p>
             <a:pPr algn="l">
               <a:spcAft>
-                <a:spcPts val="1200"/>
+                <a:spcPts val="800"/>
               </a:spcAft>
             </a:pPr>
             <a:r>
-              <a:rPr sz="1700" b="1">
+              <a:rPr sz="1500" b="1">
                 <a:solidFill>
                   <a:srgbClr val="2171B5"/>
                 </a:solidFill>
@@ -11607,7 +12110,7 @@
               <a:t>▪  </a:t>
             </a:r>
             <a:r>
-              <a:rPr sz="1700">
+              <a:rPr sz="1500">
                 <a:solidFill>
                   <a:srgbClr val="202020"/>
                 </a:solidFill>
@@ -11616,7 +12119,7 @@
               <a:t>Euphemistic rewriting (morally invariant) lowers panel-averaged harm by </a:t>
             </a:r>
             <a:r>
-              <a:rPr sz="1700" b="1">
+              <a:rPr sz="1500" b="1">
                 <a:solidFill>
                   <a:srgbClr val="D95F02"/>
                 </a:solidFill>
@@ -11625,7 +12128,7 @@
               <a:t>−14.0 points</a:t>
             </a:r>
             <a:r>
-              <a:rPr sz="1700">
+              <a:rPr sz="1500">
                 <a:solidFill>
                   <a:srgbClr val="202020"/>
                 </a:solidFill>
@@ -11637,11 +12140,11 @@
           <a:p>
             <a:pPr algn="l">
               <a:spcAft>
-                <a:spcPts val="1200"/>
+                <a:spcPts val="800"/>
               </a:spcAft>
             </a:pPr>
             <a:r>
-              <a:rPr sz="1700" b="1">
+              <a:rPr sz="1500" b="1">
                 <a:solidFill>
                   <a:srgbClr val="2171B5"/>
                 </a:solidFill>
@@ -11650,7 +12153,7 @@
               <a:t>▪  </a:t>
             </a:r>
             <a:r>
-              <a:rPr sz="1700">
+              <a:rPr sz="1500">
                 <a:solidFill>
                   <a:srgbClr val="202020"/>
                 </a:solidFill>
@@ -11659,7 +12162,7 @@
               <a:t>At a median-calibrated threshold, </a:t>
             </a:r>
             <a:r>
-              <a:rPr sz="1700" b="1">
+              <a:rPr sz="1500" b="1">
                 <a:solidFill>
                   <a:srgbClr val="D95F02"/>
                 </a:solidFill>
@@ -11668,7 +12171,7 @@
               <a:t>3 of 6</a:t>
             </a:r>
             <a:r>
-              <a:rPr sz="1700">
+              <a:rPr sz="1500">
                 <a:solidFill>
                   <a:srgbClr val="202020"/>
                 </a:solidFill>
@@ -11677,7 +12180,7 @@
               <a:t> gold items silently reclassify FLAG → PASS </a:t>
             </a:r>
             <a:r>
-              <a:rPr sz="1700" i="1">
+              <a:rPr sz="1500" i="1">
                 <a:solidFill>
                   <a:srgbClr val="202020"/>
                 </a:solidFill>
@@ -11693,7 +12196,7 @@
               </a:spcAft>
             </a:pPr>
             <a:r>
-              <a:rPr sz="1700" b="1">
+              <a:rPr sz="1500" b="1">
                 <a:solidFill>
                   <a:srgbClr val="2171B5"/>
                 </a:solidFill>
@@ -11702,7 +12205,7 @@
               <a:t>▪  </a:t>
             </a:r>
             <a:r>
-              <a:rPr sz="1700" b="1">
+              <a:rPr sz="1500" b="1">
                 <a:solidFill>
                   <a:srgbClr val="D95F02"/>
                 </a:solidFill>
@@ -11711,7 +12214,7 @@
               <a:t>Asymmetry</a:t>
             </a:r>
             <a:r>
-              <a:rPr sz="1700">
+              <a:rPr sz="1500">
                 <a:solidFill>
                   <a:srgbClr val="202020"/>
                 </a:solidFill>
@@ -11720,7 +12223,7 @@
               <a:t>: far easier to </a:t>
             </a:r>
             <a:r>
-              <a:rPr sz="1700" i="1">
+              <a:rPr sz="1500" i="1">
                 <a:solidFill>
                   <a:srgbClr val="202020"/>
                 </a:solidFill>
@@ -11729,7 +12232,7 @@
               <a:t>evade</a:t>
             </a:r>
             <a:r>
-              <a:rPr sz="1700">
+              <a:rPr sz="1500">
                 <a:solidFill>
                   <a:srgbClr val="202020"/>
                 </a:solidFill>
@@ -11738,7 +12241,7 @@
               <a:t> (hide harm) than to </a:t>
             </a:r>
             <a:r>
-              <a:rPr sz="1700" i="1">
+              <a:rPr sz="1500" i="1">
                 <a:solidFill>
                   <a:srgbClr val="202020"/>
                 </a:solidFill>
@@ -11747,13 +12250,1120 @@
               <a:t>trigger</a:t>
             </a:r>
             <a:r>
-              <a:rPr sz="1700">
+              <a:rPr sz="1500">
                 <a:solidFill>
                   <a:srgbClr val="202020"/>
                 </a:solidFill>
                 <a:latin typeface="Calibri"/>
               </a:rPr>
               <a:t> a false positive — the dangerous direction.</a:t>
+            </a:r>
+          </a:p>
+        </p:txBody>
+      </p:sp>
+      <p:sp>
+        <p:nvSpPr>
+          <p:cNvPr id="6" name="Rectangle 5"/>
+          <p:cNvSpPr/>
+          <p:nvPr/>
+        </p:nvSpPr>
+        <p:spPr>
+          <a:xfrm>
+            <a:off x="731520" y="5532120"/>
+            <a:ext cx="10698480" cy="17780"/>
+          </a:xfrm>
+          <a:prstGeom prst="rect">
+            <a:avLst/>
+          </a:prstGeom>
+          <a:solidFill>
+            <a:srgbClr val="636363"/>
+          </a:solidFill>
+          <a:ln>
+            <a:noFill/>
+          </a:ln>
+        </p:spPr>
+        <p:style>
+          <a:lnRef idx="1">
+            <a:schemeClr val="accent1"/>
+          </a:lnRef>
+          <a:fillRef idx="3">
+            <a:schemeClr val="accent1"/>
+          </a:fillRef>
+          <a:effectRef idx="2">
+            <a:schemeClr val="accent1"/>
+          </a:effectRef>
+          <a:fontRef idx="minor">
+            <a:schemeClr val="lt1"/>
+          </a:fontRef>
+        </p:style>
+        <p:txBody>
+          <a:bodyPr rtlCol="0" anchor="ctr"/>
+          <a:lstStyle/>
+          <a:p>
+            <a:pPr algn="ctr"/>
+          </a:p>
+        </p:txBody>
+      </p:sp>
+      <p:sp>
+        <p:nvSpPr>
+          <p:cNvPr id="7" name="Rectangle 6"/>
+          <p:cNvSpPr/>
+          <p:nvPr/>
+        </p:nvSpPr>
+        <p:spPr>
+          <a:xfrm>
+            <a:off x="5986913" y="4069080"/>
+            <a:ext cx="20320" cy="1600200"/>
+          </a:xfrm>
+          <a:prstGeom prst="rect">
+            <a:avLst/>
+          </a:prstGeom>
+          <a:solidFill>
+            <a:srgbClr val="1A2340"/>
+          </a:solidFill>
+          <a:ln>
+            <a:noFill/>
+          </a:ln>
+        </p:spPr>
+        <p:style>
+          <a:lnRef idx="1">
+            <a:schemeClr val="accent1"/>
+          </a:lnRef>
+          <a:fillRef idx="3">
+            <a:schemeClr val="accent1"/>
+          </a:fillRef>
+          <a:effectRef idx="2">
+            <a:schemeClr val="accent1"/>
+          </a:effectRef>
+          <a:fontRef idx="minor">
+            <a:schemeClr val="lt1"/>
+          </a:fontRef>
+        </p:style>
+        <p:txBody>
+          <a:bodyPr rtlCol="0" anchor="ctr"/>
+          <a:lstStyle/>
+          <a:p>
+            <a:pPr algn="ctr"/>
+          </a:p>
+        </p:txBody>
+      </p:sp>
+      <p:sp>
+        <p:nvSpPr>
+          <p:cNvPr id="8" name="TextBox 7"/>
+          <p:cNvSpPr txBox="1"/>
+          <p:nvPr/>
+        </p:nvSpPr>
+        <p:spPr>
+          <a:xfrm>
+            <a:off x="5255393" y="3767328"/>
+            <a:ext cx="1554480" cy="274320"/>
+          </a:xfrm>
+          <a:prstGeom prst="rect">
+            <a:avLst/>
+          </a:prstGeom>
+          <a:noFill/>
+        </p:spPr>
+        <p:txBody>
+          <a:bodyPr wrap="square">
+            <a:spAutoFit/>
+          </a:bodyPr>
+          <a:lstStyle/>
+          <a:p>
+            <a:pPr algn="ctr">
+              <a:spcAft>
+                <a:spcPts val="600"/>
+              </a:spcAft>
+            </a:pPr>
+            <a:r>
+              <a:rPr sz="1000" b="1">
+                <a:solidFill>
+                  <a:srgbClr val="202020"/>
+                </a:solidFill>
+                <a:latin typeface="Calibri"/>
+              </a:rPr>
+              <a:t>threshold T</a:t>
+            </a:r>
+          </a:p>
+        </p:txBody>
+      </p:sp>
+      <p:sp>
+        <p:nvSpPr>
+          <p:cNvPr id="9" name="TextBox 8"/>
+          <p:cNvSpPr txBox="1"/>
+          <p:nvPr/>
+        </p:nvSpPr>
+        <p:spPr>
+          <a:xfrm>
+            <a:off x="2796138" y="4069080"/>
+            <a:ext cx="1371600" cy="274320"/>
+          </a:xfrm>
+          <a:prstGeom prst="rect">
+            <a:avLst/>
+          </a:prstGeom>
+          <a:noFill/>
+        </p:spPr>
+        <p:txBody>
+          <a:bodyPr wrap="square">
+            <a:spAutoFit/>
+          </a:bodyPr>
+          <a:lstStyle/>
+          <a:p>
+            <a:pPr algn="l">
+              <a:spcAft>
+                <a:spcPts val="600"/>
+              </a:spcAft>
+            </a:pPr>
+            <a:r>
+              <a:rPr sz="900">
+                <a:solidFill>
+                  <a:srgbClr val="636363"/>
+                </a:solidFill>
+                <a:latin typeface="Calibri"/>
+              </a:rPr>
+              <a:t>PASS side</a:t>
+            </a:r>
+          </a:p>
+        </p:txBody>
+      </p:sp>
+      <p:sp>
+        <p:nvSpPr>
+          <p:cNvPr id="10" name="TextBox 9"/>
+          <p:cNvSpPr txBox="1"/>
+          <p:nvPr/>
+        </p:nvSpPr>
+        <p:spPr>
+          <a:xfrm>
+            <a:off x="8239225" y="4069080"/>
+            <a:ext cx="1371600" cy="274320"/>
+          </a:xfrm>
+          <a:prstGeom prst="rect">
+            <a:avLst/>
+          </a:prstGeom>
+          <a:noFill/>
+        </p:spPr>
+        <p:txBody>
+          <a:bodyPr wrap="square">
+            <a:spAutoFit/>
+          </a:bodyPr>
+          <a:lstStyle/>
+          <a:p>
+            <a:pPr algn="l">
+              <a:spcAft>
+                <a:spcPts val="600"/>
+              </a:spcAft>
+            </a:pPr>
+            <a:r>
+              <a:rPr sz="900">
+                <a:solidFill>
+                  <a:srgbClr val="636363"/>
+                </a:solidFill>
+                <a:latin typeface="Calibri"/>
+              </a:rPr>
+              <a:t>FLAG side</a:t>
+            </a:r>
+          </a:p>
+        </p:txBody>
+      </p:sp>
+      <p:sp>
+        <p:nvSpPr>
+          <p:cNvPr id="11" name="Left Arrow 10"/>
+          <p:cNvSpPr/>
+          <p:nvPr/>
+        </p:nvSpPr>
+        <p:spPr>
+          <a:xfrm>
+            <a:off x="4579218" y="4480560"/>
+            <a:ext cx="2064619" cy="91440"/>
+          </a:xfrm>
+          <a:prstGeom prst="leftArrow">
+            <a:avLst>
+              <a:gd name="adj1" fmla="val 50000"/>
+              <a:gd name="adj2" fmla="val 50000"/>
+            </a:avLst>
+          </a:prstGeom>
+          <a:solidFill>
+            <a:srgbClr val="D95F02"/>
+          </a:solidFill>
+          <a:ln>
+            <a:noFill/>
+          </a:ln>
+        </p:spPr>
+        <p:style>
+          <a:lnRef idx="1">
+            <a:schemeClr val="accent1"/>
+          </a:lnRef>
+          <a:fillRef idx="3">
+            <a:schemeClr val="accent1"/>
+          </a:fillRef>
+          <a:effectRef idx="2">
+            <a:schemeClr val="accent1"/>
+          </a:effectRef>
+          <a:fontRef idx="minor">
+            <a:schemeClr val="lt1"/>
+          </a:fontRef>
+        </p:style>
+        <p:txBody>
+          <a:bodyPr rtlCol="0" anchor="ctr"/>
+          <a:lstStyle/>
+          <a:p>
+            <a:pPr algn="ctr"/>
+          </a:p>
+        </p:txBody>
+      </p:sp>
+      <p:sp>
+        <p:nvSpPr>
+          <p:cNvPr id="12" name="Oval 11"/>
+          <p:cNvSpPr/>
+          <p:nvPr/>
+        </p:nvSpPr>
+        <p:spPr>
+          <a:xfrm>
+            <a:off x="6593545" y="4475988"/>
+            <a:ext cx="100584" cy="100584"/>
+          </a:xfrm>
+          <a:prstGeom prst="ellipse">
+            <a:avLst/>
+          </a:prstGeom>
+          <a:solidFill>
+            <a:srgbClr val="2171B5"/>
+          </a:solidFill>
+          <a:ln>
+            <a:noFill/>
+          </a:ln>
+        </p:spPr>
+        <p:style>
+          <a:lnRef idx="1">
+            <a:schemeClr val="accent1"/>
+          </a:lnRef>
+          <a:fillRef idx="3">
+            <a:schemeClr val="accent1"/>
+          </a:fillRef>
+          <a:effectRef idx="2">
+            <a:schemeClr val="accent1"/>
+          </a:effectRef>
+          <a:fontRef idx="minor">
+            <a:schemeClr val="lt1"/>
+          </a:fontRef>
+        </p:style>
+        <p:txBody>
+          <a:bodyPr rtlCol="0" anchor="ctr"/>
+          <a:lstStyle/>
+          <a:p>
+            <a:pPr algn="ctr"/>
+          </a:p>
+        </p:txBody>
+      </p:sp>
+      <p:sp>
+        <p:nvSpPr>
+          <p:cNvPr id="13" name="Oval 12"/>
+          <p:cNvSpPr/>
+          <p:nvPr/>
+        </p:nvSpPr>
+        <p:spPr>
+          <a:xfrm>
+            <a:off x="4528926" y="4475988"/>
+            <a:ext cx="100584" cy="100584"/>
+          </a:xfrm>
+          <a:prstGeom prst="ellipse">
+            <a:avLst/>
+          </a:prstGeom>
+          <a:solidFill>
+            <a:srgbClr val="D95F02"/>
+          </a:solidFill>
+          <a:ln>
+            <a:noFill/>
+          </a:ln>
+        </p:spPr>
+        <p:style>
+          <a:lnRef idx="1">
+            <a:schemeClr val="accent1"/>
+          </a:lnRef>
+          <a:fillRef idx="3">
+            <a:schemeClr val="accent1"/>
+          </a:fillRef>
+          <a:effectRef idx="2">
+            <a:schemeClr val="accent1"/>
+          </a:effectRef>
+          <a:fontRef idx="minor">
+            <a:schemeClr val="lt1"/>
+          </a:fontRef>
+        </p:style>
+        <p:txBody>
+          <a:bodyPr rtlCol="0" anchor="ctr"/>
+          <a:lstStyle/>
+          <a:p>
+            <a:pPr algn="ctr"/>
+          </a:p>
+        </p:txBody>
+      </p:sp>
+      <p:sp>
+        <p:nvSpPr>
+          <p:cNvPr id="14" name="Left Arrow 13"/>
+          <p:cNvSpPr/>
+          <p:nvPr/>
+        </p:nvSpPr>
+        <p:spPr>
+          <a:xfrm>
+            <a:off x="5329989" y="4754880"/>
+            <a:ext cx="2158465" cy="91440"/>
+          </a:xfrm>
+          <a:prstGeom prst="leftArrow">
+            <a:avLst>
+              <a:gd name="adj1" fmla="val 50000"/>
+              <a:gd name="adj2" fmla="val 50000"/>
+            </a:avLst>
+          </a:prstGeom>
+          <a:solidFill>
+            <a:srgbClr val="D95F02"/>
+          </a:solidFill>
+          <a:ln>
+            <a:noFill/>
+          </a:ln>
+        </p:spPr>
+        <p:style>
+          <a:lnRef idx="1">
+            <a:schemeClr val="accent1"/>
+          </a:lnRef>
+          <a:fillRef idx="3">
+            <a:schemeClr val="accent1"/>
+          </a:fillRef>
+          <a:effectRef idx="2">
+            <a:schemeClr val="accent1"/>
+          </a:effectRef>
+          <a:fontRef idx="minor">
+            <a:schemeClr val="lt1"/>
+          </a:fontRef>
+        </p:style>
+        <p:txBody>
+          <a:bodyPr rtlCol="0" anchor="ctr"/>
+          <a:lstStyle/>
+          <a:p>
+            <a:pPr algn="ctr"/>
+          </a:p>
+        </p:txBody>
+      </p:sp>
+      <p:sp>
+        <p:nvSpPr>
+          <p:cNvPr id="15" name="Oval 14"/>
+          <p:cNvSpPr/>
+          <p:nvPr/>
+        </p:nvSpPr>
+        <p:spPr>
+          <a:xfrm>
+            <a:off x="7438162" y="4750308"/>
+            <a:ext cx="100584" cy="100584"/>
+          </a:xfrm>
+          <a:prstGeom prst="ellipse">
+            <a:avLst/>
+          </a:prstGeom>
+          <a:solidFill>
+            <a:srgbClr val="2171B5"/>
+          </a:solidFill>
+          <a:ln>
+            <a:noFill/>
+          </a:ln>
+        </p:spPr>
+        <p:style>
+          <a:lnRef idx="1">
+            <a:schemeClr val="accent1"/>
+          </a:lnRef>
+          <a:fillRef idx="3">
+            <a:schemeClr val="accent1"/>
+          </a:fillRef>
+          <a:effectRef idx="2">
+            <a:schemeClr val="accent1"/>
+          </a:effectRef>
+          <a:fontRef idx="minor">
+            <a:schemeClr val="lt1"/>
+          </a:fontRef>
+        </p:style>
+        <p:txBody>
+          <a:bodyPr rtlCol="0" anchor="ctr"/>
+          <a:lstStyle/>
+          <a:p>
+            <a:pPr algn="ctr"/>
+          </a:p>
+        </p:txBody>
+      </p:sp>
+      <p:sp>
+        <p:nvSpPr>
+          <p:cNvPr id="16" name="Oval 15"/>
+          <p:cNvSpPr/>
+          <p:nvPr/>
+        </p:nvSpPr>
+        <p:spPr>
+          <a:xfrm>
+            <a:off x="5279697" y="4750308"/>
+            <a:ext cx="100584" cy="100584"/>
+          </a:xfrm>
+          <a:prstGeom prst="ellipse">
+            <a:avLst/>
+          </a:prstGeom>
+          <a:solidFill>
+            <a:srgbClr val="D95F02"/>
+          </a:solidFill>
+          <a:ln>
+            <a:noFill/>
+          </a:ln>
+        </p:spPr>
+        <p:style>
+          <a:lnRef idx="1">
+            <a:schemeClr val="accent1"/>
+          </a:lnRef>
+          <a:fillRef idx="3">
+            <a:schemeClr val="accent1"/>
+          </a:fillRef>
+          <a:effectRef idx="2">
+            <a:schemeClr val="accent1"/>
+          </a:effectRef>
+          <a:fontRef idx="minor">
+            <a:schemeClr val="lt1"/>
+          </a:fontRef>
+        </p:style>
+        <p:txBody>
+          <a:bodyPr rtlCol="0" anchor="ctr"/>
+          <a:lstStyle/>
+          <a:p>
+            <a:pPr algn="ctr"/>
+          </a:p>
+        </p:txBody>
+      </p:sp>
+      <p:sp>
+        <p:nvSpPr>
+          <p:cNvPr id="17" name="Left Arrow 16"/>
+          <p:cNvSpPr/>
+          <p:nvPr/>
+        </p:nvSpPr>
+        <p:spPr>
+          <a:xfrm>
+            <a:off x="5611528" y="5029200"/>
+            <a:ext cx="3003082" cy="91440"/>
+          </a:xfrm>
+          <a:prstGeom prst="leftArrow">
+            <a:avLst>
+              <a:gd name="adj1" fmla="val 50000"/>
+              <a:gd name="adj2" fmla="val 50000"/>
+            </a:avLst>
+          </a:prstGeom>
+          <a:solidFill>
+            <a:srgbClr val="D95F02"/>
+          </a:solidFill>
+          <a:ln>
+            <a:noFill/>
+          </a:ln>
+        </p:spPr>
+        <p:style>
+          <a:lnRef idx="1">
+            <a:schemeClr val="accent1"/>
+          </a:lnRef>
+          <a:fillRef idx="3">
+            <a:schemeClr val="accent1"/>
+          </a:fillRef>
+          <a:effectRef idx="2">
+            <a:schemeClr val="accent1"/>
+          </a:effectRef>
+          <a:fontRef idx="minor">
+            <a:schemeClr val="lt1"/>
+          </a:fontRef>
+        </p:style>
+        <p:txBody>
+          <a:bodyPr rtlCol="0" anchor="ctr"/>
+          <a:lstStyle/>
+          <a:p>
+            <a:pPr algn="ctr"/>
+          </a:p>
+        </p:txBody>
+      </p:sp>
+      <p:sp>
+        <p:nvSpPr>
+          <p:cNvPr id="18" name="Oval 17"/>
+          <p:cNvSpPr/>
+          <p:nvPr/>
+        </p:nvSpPr>
+        <p:spPr>
+          <a:xfrm>
+            <a:off x="8564318" y="5024628"/>
+            <a:ext cx="100584" cy="100584"/>
+          </a:xfrm>
+          <a:prstGeom prst="ellipse">
+            <a:avLst/>
+          </a:prstGeom>
+          <a:solidFill>
+            <a:srgbClr val="2171B5"/>
+          </a:solidFill>
+          <a:ln>
+            <a:noFill/>
+          </a:ln>
+        </p:spPr>
+        <p:style>
+          <a:lnRef idx="1">
+            <a:schemeClr val="accent1"/>
+          </a:lnRef>
+          <a:fillRef idx="3">
+            <a:schemeClr val="accent1"/>
+          </a:fillRef>
+          <a:effectRef idx="2">
+            <a:schemeClr val="accent1"/>
+          </a:effectRef>
+          <a:fontRef idx="minor">
+            <a:schemeClr val="lt1"/>
+          </a:fontRef>
+        </p:style>
+        <p:txBody>
+          <a:bodyPr rtlCol="0" anchor="ctr"/>
+          <a:lstStyle/>
+          <a:p>
+            <a:pPr algn="ctr"/>
+          </a:p>
+        </p:txBody>
+      </p:sp>
+      <p:sp>
+        <p:nvSpPr>
+          <p:cNvPr id="19" name="Oval 18"/>
+          <p:cNvSpPr/>
+          <p:nvPr/>
+        </p:nvSpPr>
+        <p:spPr>
+          <a:xfrm>
+            <a:off x="5561236" y="5024628"/>
+            <a:ext cx="100584" cy="100584"/>
+          </a:xfrm>
+          <a:prstGeom prst="ellipse">
+            <a:avLst/>
+          </a:prstGeom>
+          <a:solidFill>
+            <a:srgbClr val="D95F02"/>
+          </a:solidFill>
+          <a:ln>
+            <a:noFill/>
+          </a:ln>
+        </p:spPr>
+        <p:style>
+          <a:lnRef idx="1">
+            <a:schemeClr val="accent1"/>
+          </a:lnRef>
+          <a:fillRef idx="3">
+            <a:schemeClr val="accent1"/>
+          </a:fillRef>
+          <a:effectRef idx="2">
+            <a:schemeClr val="accent1"/>
+          </a:effectRef>
+          <a:fontRef idx="minor">
+            <a:schemeClr val="lt1"/>
+          </a:fontRef>
+        </p:style>
+        <p:txBody>
+          <a:bodyPr rtlCol="0" anchor="ctr"/>
+          <a:lstStyle/>
+          <a:p>
+            <a:pPr algn="ctr"/>
+          </a:p>
+        </p:txBody>
+      </p:sp>
+      <p:sp>
+        <p:nvSpPr>
+          <p:cNvPr id="20" name="Left Arrow 19"/>
+          <p:cNvSpPr/>
+          <p:nvPr/>
+        </p:nvSpPr>
+        <p:spPr>
+          <a:xfrm>
+            <a:off x="6456145" y="4480560"/>
+            <a:ext cx="1689233" cy="91440"/>
+          </a:xfrm>
+          <a:prstGeom prst="leftArrow">
+            <a:avLst>
+              <a:gd name="adj1" fmla="val 50000"/>
+              <a:gd name="adj2" fmla="val 50000"/>
+            </a:avLst>
+          </a:prstGeom>
+          <a:solidFill>
+            <a:srgbClr val="D95F02"/>
+          </a:solidFill>
+          <a:ln>
+            <a:noFill/>
+          </a:ln>
+        </p:spPr>
+        <p:style>
+          <a:lnRef idx="1">
+            <a:schemeClr val="accent1"/>
+          </a:lnRef>
+          <a:fillRef idx="3">
+            <a:schemeClr val="accent1"/>
+          </a:fillRef>
+          <a:effectRef idx="2">
+            <a:schemeClr val="accent1"/>
+          </a:effectRef>
+          <a:fontRef idx="minor">
+            <a:schemeClr val="lt1"/>
+          </a:fontRef>
+        </p:style>
+        <p:txBody>
+          <a:bodyPr rtlCol="0" anchor="ctr"/>
+          <a:lstStyle/>
+          <a:p>
+            <a:pPr algn="ctr"/>
+          </a:p>
+        </p:txBody>
+      </p:sp>
+      <p:sp>
+        <p:nvSpPr>
+          <p:cNvPr id="21" name="Oval 20"/>
+          <p:cNvSpPr/>
+          <p:nvPr/>
+        </p:nvSpPr>
+        <p:spPr>
+          <a:xfrm>
+            <a:off x="8095086" y="4475988"/>
+            <a:ext cx="100584" cy="100584"/>
+          </a:xfrm>
+          <a:prstGeom prst="ellipse">
+            <a:avLst/>
+          </a:prstGeom>
+          <a:solidFill>
+            <a:srgbClr val="2171B5"/>
+          </a:solidFill>
+          <a:ln>
+            <a:noFill/>
+          </a:ln>
+        </p:spPr>
+        <p:style>
+          <a:lnRef idx="1">
+            <a:schemeClr val="accent1"/>
+          </a:lnRef>
+          <a:fillRef idx="3">
+            <a:schemeClr val="accent1"/>
+          </a:fillRef>
+          <a:effectRef idx="2">
+            <a:schemeClr val="accent1"/>
+          </a:effectRef>
+          <a:fontRef idx="minor">
+            <a:schemeClr val="lt1"/>
+          </a:fontRef>
+        </p:style>
+        <p:txBody>
+          <a:bodyPr rtlCol="0" anchor="ctr"/>
+          <a:lstStyle/>
+          <a:p>
+            <a:pPr algn="ctr"/>
+          </a:p>
+        </p:txBody>
+      </p:sp>
+      <p:sp>
+        <p:nvSpPr>
+          <p:cNvPr id="22" name="Oval 21"/>
+          <p:cNvSpPr/>
+          <p:nvPr/>
+        </p:nvSpPr>
+        <p:spPr>
+          <a:xfrm>
+            <a:off x="6405853" y="4475988"/>
+            <a:ext cx="100584" cy="100584"/>
+          </a:xfrm>
+          <a:prstGeom prst="ellipse">
+            <a:avLst/>
+          </a:prstGeom>
+          <a:solidFill>
+            <a:srgbClr val="D95F02"/>
+          </a:solidFill>
+          <a:ln>
+            <a:noFill/>
+          </a:ln>
+        </p:spPr>
+        <p:style>
+          <a:lnRef idx="1">
+            <a:schemeClr val="accent1"/>
+          </a:lnRef>
+          <a:fillRef idx="3">
+            <a:schemeClr val="accent1"/>
+          </a:fillRef>
+          <a:effectRef idx="2">
+            <a:schemeClr val="accent1"/>
+          </a:effectRef>
+          <a:fontRef idx="minor">
+            <a:schemeClr val="lt1"/>
+          </a:fontRef>
+        </p:style>
+        <p:txBody>
+          <a:bodyPr rtlCol="0" anchor="ctr"/>
+          <a:lstStyle/>
+          <a:p>
+            <a:pPr algn="ctr"/>
+          </a:p>
+        </p:txBody>
+      </p:sp>
+      <p:sp>
+        <p:nvSpPr>
+          <p:cNvPr id="23" name="Left Arrow 22"/>
+          <p:cNvSpPr/>
+          <p:nvPr/>
+        </p:nvSpPr>
+        <p:spPr>
+          <a:xfrm>
+            <a:off x="7676147" y="4754880"/>
+            <a:ext cx="1783080" cy="91440"/>
+          </a:xfrm>
+          <a:prstGeom prst="leftArrow">
+            <a:avLst>
+              <a:gd name="adj1" fmla="val 50000"/>
+              <a:gd name="adj2" fmla="val 50000"/>
+            </a:avLst>
+          </a:prstGeom>
+          <a:solidFill>
+            <a:srgbClr val="D95F02"/>
+          </a:solidFill>
+          <a:ln>
+            <a:noFill/>
+          </a:ln>
+        </p:spPr>
+        <p:style>
+          <a:lnRef idx="1">
+            <a:schemeClr val="accent1"/>
+          </a:lnRef>
+          <a:fillRef idx="3">
+            <a:schemeClr val="accent1"/>
+          </a:fillRef>
+          <a:effectRef idx="2">
+            <a:schemeClr val="accent1"/>
+          </a:effectRef>
+          <a:fontRef idx="minor">
+            <a:schemeClr val="lt1"/>
+          </a:fontRef>
+        </p:style>
+        <p:txBody>
+          <a:bodyPr rtlCol="0" anchor="ctr"/>
+          <a:lstStyle/>
+          <a:p>
+            <a:pPr algn="ctr"/>
+          </a:p>
+        </p:txBody>
+      </p:sp>
+      <p:sp>
+        <p:nvSpPr>
+          <p:cNvPr id="24" name="Oval 23"/>
+          <p:cNvSpPr/>
+          <p:nvPr/>
+        </p:nvSpPr>
+        <p:spPr>
+          <a:xfrm>
+            <a:off x="9408935" y="4750308"/>
+            <a:ext cx="100584" cy="100584"/>
+          </a:xfrm>
+          <a:prstGeom prst="ellipse">
+            <a:avLst/>
+          </a:prstGeom>
+          <a:solidFill>
+            <a:srgbClr val="2171B5"/>
+          </a:solidFill>
+          <a:ln>
+            <a:noFill/>
+          </a:ln>
+        </p:spPr>
+        <p:style>
+          <a:lnRef idx="1">
+            <a:schemeClr val="accent1"/>
+          </a:lnRef>
+          <a:fillRef idx="3">
+            <a:schemeClr val="accent1"/>
+          </a:fillRef>
+          <a:effectRef idx="2">
+            <a:schemeClr val="accent1"/>
+          </a:effectRef>
+          <a:fontRef idx="minor">
+            <a:schemeClr val="lt1"/>
+          </a:fontRef>
+        </p:style>
+        <p:txBody>
+          <a:bodyPr rtlCol="0" anchor="ctr"/>
+          <a:lstStyle/>
+          <a:p>
+            <a:pPr algn="ctr"/>
+          </a:p>
+        </p:txBody>
+      </p:sp>
+      <p:sp>
+        <p:nvSpPr>
+          <p:cNvPr id="25" name="Oval 24"/>
+          <p:cNvSpPr/>
+          <p:nvPr/>
+        </p:nvSpPr>
+        <p:spPr>
+          <a:xfrm>
+            <a:off x="7625855" y="4750308"/>
+            <a:ext cx="100584" cy="100584"/>
+          </a:xfrm>
+          <a:prstGeom prst="ellipse">
+            <a:avLst/>
+          </a:prstGeom>
+          <a:solidFill>
+            <a:srgbClr val="D95F02"/>
+          </a:solidFill>
+          <a:ln>
+            <a:noFill/>
+          </a:ln>
+        </p:spPr>
+        <p:style>
+          <a:lnRef idx="1">
+            <a:schemeClr val="accent1"/>
+          </a:lnRef>
+          <a:fillRef idx="3">
+            <a:schemeClr val="accent1"/>
+          </a:fillRef>
+          <a:effectRef idx="2">
+            <a:schemeClr val="accent1"/>
+          </a:effectRef>
+          <a:fontRef idx="minor">
+            <a:schemeClr val="lt1"/>
+          </a:fontRef>
+        </p:style>
+        <p:txBody>
+          <a:bodyPr rtlCol="0" anchor="ctr"/>
+          <a:lstStyle/>
+          <a:p>
+            <a:pPr algn="ctr"/>
+          </a:p>
+        </p:txBody>
+      </p:sp>
+      <p:sp>
+        <p:nvSpPr>
+          <p:cNvPr id="26" name="Left Arrow 25"/>
+          <p:cNvSpPr/>
+          <p:nvPr/>
+        </p:nvSpPr>
+        <p:spPr>
+          <a:xfrm>
+            <a:off x="8802303" y="5029200"/>
+            <a:ext cx="1689233" cy="91440"/>
+          </a:xfrm>
+          <a:prstGeom prst="leftArrow">
+            <a:avLst>
+              <a:gd name="adj1" fmla="val 50000"/>
+              <a:gd name="adj2" fmla="val 50000"/>
+            </a:avLst>
+          </a:prstGeom>
+          <a:solidFill>
+            <a:srgbClr val="D95F02"/>
+          </a:solidFill>
+          <a:ln>
+            <a:noFill/>
+          </a:ln>
+        </p:spPr>
+        <p:style>
+          <a:lnRef idx="1">
+            <a:schemeClr val="accent1"/>
+          </a:lnRef>
+          <a:fillRef idx="3">
+            <a:schemeClr val="accent1"/>
+          </a:fillRef>
+          <a:effectRef idx="2">
+            <a:schemeClr val="accent1"/>
+          </a:effectRef>
+          <a:fontRef idx="minor">
+            <a:schemeClr val="lt1"/>
+          </a:fontRef>
+        </p:style>
+        <p:txBody>
+          <a:bodyPr rtlCol="0" anchor="ctr"/>
+          <a:lstStyle/>
+          <a:p>
+            <a:pPr algn="ctr"/>
+          </a:p>
+        </p:txBody>
+      </p:sp>
+      <p:sp>
+        <p:nvSpPr>
+          <p:cNvPr id="27" name="Oval 26"/>
+          <p:cNvSpPr/>
+          <p:nvPr/>
+        </p:nvSpPr>
+        <p:spPr>
+          <a:xfrm>
+            <a:off x="10441244" y="5024628"/>
+            <a:ext cx="100584" cy="100584"/>
+          </a:xfrm>
+          <a:prstGeom prst="ellipse">
+            <a:avLst/>
+          </a:prstGeom>
+          <a:solidFill>
+            <a:srgbClr val="2171B5"/>
+          </a:solidFill>
+          <a:ln>
+            <a:noFill/>
+          </a:ln>
+        </p:spPr>
+        <p:style>
+          <a:lnRef idx="1">
+            <a:schemeClr val="accent1"/>
+          </a:lnRef>
+          <a:fillRef idx="3">
+            <a:schemeClr val="accent1"/>
+          </a:fillRef>
+          <a:effectRef idx="2">
+            <a:schemeClr val="accent1"/>
+          </a:effectRef>
+          <a:fontRef idx="minor">
+            <a:schemeClr val="lt1"/>
+          </a:fontRef>
+        </p:style>
+        <p:txBody>
+          <a:bodyPr rtlCol="0" anchor="ctr"/>
+          <a:lstStyle/>
+          <a:p>
+            <a:pPr algn="ctr"/>
+          </a:p>
+        </p:txBody>
+      </p:sp>
+      <p:sp>
+        <p:nvSpPr>
+          <p:cNvPr id="28" name="Oval 27"/>
+          <p:cNvSpPr/>
+          <p:nvPr/>
+        </p:nvSpPr>
+        <p:spPr>
+          <a:xfrm>
+            <a:off x="8752011" y="5024628"/>
+            <a:ext cx="100584" cy="100584"/>
+          </a:xfrm>
+          <a:prstGeom prst="ellipse">
+            <a:avLst/>
+          </a:prstGeom>
+          <a:solidFill>
+            <a:srgbClr val="D95F02"/>
+          </a:solidFill>
+          <a:ln>
+            <a:noFill/>
+          </a:ln>
+        </p:spPr>
+        <p:style>
+          <a:lnRef idx="1">
+            <a:schemeClr val="accent1"/>
+          </a:lnRef>
+          <a:fillRef idx="3">
+            <a:schemeClr val="accent1"/>
+          </a:fillRef>
+          <a:effectRef idx="2">
+            <a:schemeClr val="accent1"/>
+          </a:effectRef>
+          <a:fontRef idx="minor">
+            <a:schemeClr val="lt1"/>
+          </a:fontRef>
+        </p:style>
+        <p:txBody>
+          <a:bodyPr rtlCol="0" anchor="ctr"/>
+          <a:lstStyle/>
+          <a:p>
+            <a:pPr algn="ctr"/>
+          </a:p>
+        </p:txBody>
+      </p:sp>
+      <p:sp>
+        <p:nvSpPr>
+          <p:cNvPr id="29" name="TextBox 28"/>
+          <p:cNvSpPr txBox="1"/>
+          <p:nvPr/>
+        </p:nvSpPr>
+        <p:spPr>
+          <a:xfrm>
+            <a:off x="777240" y="4343400"/>
+            <a:ext cx="2011680" cy="548640"/>
+          </a:xfrm>
+          <a:prstGeom prst="rect">
+            <a:avLst/>
+          </a:prstGeom>
+          <a:noFill/>
+        </p:spPr>
+        <p:txBody>
+          <a:bodyPr wrap="square">
+            <a:spAutoFit/>
+          </a:bodyPr>
+          <a:lstStyle/>
+          <a:p>
+            <a:pPr algn="l">
+              <a:spcAft>
+                <a:spcPts val="100"/>
+              </a:spcAft>
+            </a:pPr>
+            <a:r>
+              <a:rPr sz="900" b="1">
+                <a:solidFill>
+                  <a:srgbClr val="2171B5"/>
+                </a:solidFill>
+                <a:latin typeface="Calibri"/>
+              </a:rPr>
+              <a:t>●</a:t>
+            </a:r>
+            <a:r>
+              <a:rPr sz="900">
+                <a:solidFill>
+                  <a:srgbClr val="636363"/>
+                </a:solidFill>
+                <a:latin typeface="Calibri"/>
+              </a:rPr>
+              <a:t> original</a:t>
+            </a:r>
+          </a:p>
+          <a:p>
+            <a:pPr algn="l">
+              <a:spcAft>
+                <a:spcPts val="600"/>
+              </a:spcAft>
+            </a:pPr>
+            <a:r>
+              <a:rPr sz="900" b="1">
+                <a:solidFill>
+                  <a:srgbClr val="D95F02"/>
+                </a:solidFill>
+                <a:latin typeface="Calibri"/>
+              </a:rPr>
+              <a:t>●</a:t>
+            </a:r>
+            <a:r>
+              <a:rPr sz="900">
+                <a:solidFill>
+                  <a:srgbClr val="636363"/>
+                </a:solidFill>
+                <a:latin typeface="Calibri"/>
+              </a:rPr>
+              <a:t> euphemistic</a:t>
+            </a:r>
+          </a:p>
+        </p:txBody>
+      </p:sp>
+      <p:sp>
+        <p:nvSpPr>
+          <p:cNvPr id="30" name="TextBox 29"/>
+          <p:cNvSpPr txBox="1"/>
+          <p:nvPr/>
+        </p:nvSpPr>
+        <p:spPr>
+          <a:xfrm>
+            <a:off x="6035040" y="5715000"/>
+            <a:ext cx="5486400" cy="274320"/>
+          </a:xfrm>
+          <a:prstGeom prst="rect">
+            <a:avLst/>
+          </a:prstGeom>
+          <a:noFill/>
+        </p:spPr>
+        <p:txBody>
+          <a:bodyPr wrap="square">
+            <a:spAutoFit/>
+          </a:bodyPr>
+          <a:lstStyle/>
+          <a:p>
+            <a:pPr algn="r">
+              <a:spcAft>
+                <a:spcPts val="600"/>
+              </a:spcAft>
+            </a:pPr>
+            <a:r>
+              <a:rPr sz="900">
+                <a:solidFill>
+                  <a:srgbClr val="636363"/>
+                </a:solidFill>
+                <a:latin typeface="Calibri"/>
+              </a:rPr>
+              <a:t>schematic geometry — the measured statistics are the bullets above</a:t>
             </a:r>
           </a:p>
         </p:txBody>
@@ -11900,8 +13510,8 @@
         </p:nvSpPr>
         <p:spPr>
           <a:xfrm>
-            <a:off x="502920" y="868680"/>
-            <a:ext cx="11155680" cy="1188720"/>
+            <a:off x="502920" y="841248"/>
+            <a:ext cx="11155680" cy="411480"/>
           </a:xfrm>
           <a:prstGeom prst="rect">
             <a:avLst/>
@@ -11920,7 +13530,7 @@
               </a:spcAft>
             </a:pPr>
             <a:r>
-              <a:rPr sz="1600">
+              <a:rPr sz="1500">
                 <a:solidFill>
                   <a:srgbClr val="202020"/>
                 </a:solidFill>
@@ -11929,7 +13539,7 @@
               <a:t>Route each scenario through the real </a:t>
             </a:r>
             <a:r>
-              <a:rPr sz="1600" b="1">
+              <a:rPr sz="1500" b="1">
                 <a:solidFill>
                   <a:srgbClr val="2171B5"/>
                 </a:solidFill>
@@ -11938,7 +13548,7 @@
               <a:t>ErisML DEME v3</a:t>
             </a:r>
             <a:r>
-              <a:rPr sz="1600">
+              <a:rPr sz="1500">
                 <a:solidFill>
                   <a:srgbClr val="202020"/>
                 </a:solidFill>
@@ -11947,6 +13557,515 @@
               <a:t> decision kernel:</a:t>
             </a:r>
           </a:p>
+        </p:txBody>
+      </p:sp>
+      <p:sp>
+        <p:nvSpPr>
+          <p:cNvPr id="6" name="Rounded Rectangle 5"/>
+          <p:cNvSpPr/>
+          <p:nvPr/>
+        </p:nvSpPr>
+        <p:spPr>
+          <a:xfrm>
+            <a:off x="914400" y="1783080"/>
+            <a:ext cx="1737360" cy="566928"/>
+          </a:xfrm>
+          <a:prstGeom prst="roundRect">
+            <a:avLst>
+              <a:gd name="adj" fmla="val 10000"/>
+            </a:avLst>
+          </a:prstGeom>
+          <a:solidFill>
+            <a:srgbClr val="EEF4FA"/>
+          </a:solidFill>
+          <a:ln w="15240">
+            <a:solidFill>
+              <a:srgbClr val="2171B5"/>
+            </a:solidFill>
+          </a:ln>
+        </p:spPr>
+        <p:style>
+          <a:lnRef idx="1">
+            <a:schemeClr val="accent1"/>
+          </a:lnRef>
+          <a:fillRef idx="3">
+            <a:schemeClr val="accent1"/>
+          </a:fillRef>
+          <a:effectRef idx="2">
+            <a:schemeClr val="accent1"/>
+          </a:effectRef>
+          <a:fontRef idx="minor">
+            <a:schemeClr val="lt1"/>
+          </a:fontRef>
+        </p:style>
+        <p:txBody>
+          <a:bodyPr rtlCol="0" anchor="ctr" wrap="square" lIns="27432" rIns="27432" tIns="18288" bIns="18288"/>
+          <a:lstStyle/>
+          <a:p>
+            <a:pPr algn="ctr"/>
+            <a:r>
+              <a:rPr sz="1100">
+                <a:solidFill>
+                  <a:srgbClr val="202020"/>
+                </a:solidFill>
+                <a:latin typeface="Calibri"/>
+              </a:rPr>
+              <a:t>scenario text</a:t>
+            </a:r>
+          </a:p>
+        </p:txBody>
+      </p:sp>
+      <p:sp>
+        <p:nvSpPr>
+          <p:cNvPr id="7" name="Rounded Rectangle 6"/>
+          <p:cNvSpPr/>
+          <p:nvPr/>
+        </p:nvSpPr>
+        <p:spPr>
+          <a:xfrm>
+            <a:off x="3200400" y="1783080"/>
+            <a:ext cx="2103120" cy="566928"/>
+          </a:xfrm>
+          <a:prstGeom prst="roundRect">
+            <a:avLst>
+              <a:gd name="adj" fmla="val 10000"/>
+            </a:avLst>
+          </a:prstGeom>
+          <a:solidFill>
+            <a:srgbClr val="EEF4FA"/>
+          </a:solidFill>
+          <a:ln w="15240">
+            <a:solidFill>
+              <a:srgbClr val="2171B5"/>
+            </a:solidFill>
+          </a:ln>
+        </p:spPr>
+        <p:style>
+          <a:lnRef idx="1">
+            <a:schemeClr val="accent1"/>
+          </a:lnRef>
+          <a:fillRef idx="3">
+            <a:schemeClr val="accent1"/>
+          </a:fillRef>
+          <a:effectRef idx="2">
+            <a:schemeClr val="accent1"/>
+          </a:effectRef>
+          <a:fontRef idx="minor">
+            <a:schemeClr val="lt1"/>
+          </a:fontRef>
+        </p:style>
+        <p:txBody>
+          <a:bodyPr rtlCol="0" anchor="ctr" wrap="square" lIns="27432" rIns="27432" tIns="18288" bIns="18288"/>
+          <a:lstStyle/>
+          <a:p>
+            <a:pPr algn="ctr"/>
+            <a:r>
+              <a:rPr sz="1100">
+                <a:solidFill>
+                  <a:srgbClr val="202020"/>
+                </a:solidFill>
+                <a:latin typeface="Calibri"/>
+              </a:rPr>
+              <a:t>LLM extracts
+</a:t>
+            </a:r>
+            <a:r>
+              <a:rPr sz="1100" b="1">
+                <a:solidFill>
+                  <a:srgbClr val="202020"/>
+                </a:solidFill>
+                <a:latin typeface="Calibri"/>
+              </a:rPr>
+              <a:t>ethical facts</a:t>
+            </a:r>
+          </a:p>
+        </p:txBody>
+      </p:sp>
+      <p:sp>
+        <p:nvSpPr>
+          <p:cNvPr id="8" name="Rounded Rectangle 7"/>
+          <p:cNvSpPr/>
+          <p:nvPr/>
+        </p:nvSpPr>
+        <p:spPr>
+          <a:xfrm>
+            <a:off x="5897880" y="1783080"/>
+            <a:ext cx="2286000" cy="566928"/>
+          </a:xfrm>
+          <a:prstGeom prst="roundRect">
+            <a:avLst>
+              <a:gd name="adj" fmla="val 10000"/>
+            </a:avLst>
+          </a:prstGeom>
+          <a:solidFill>
+            <a:srgbClr val="F3F3F3"/>
+          </a:solidFill>
+          <a:ln w="15240">
+            <a:solidFill>
+              <a:srgbClr val="636363"/>
+            </a:solidFill>
+          </a:ln>
+        </p:spPr>
+        <p:style>
+          <a:lnRef idx="1">
+            <a:schemeClr val="accent1"/>
+          </a:lnRef>
+          <a:fillRef idx="3">
+            <a:schemeClr val="accent1"/>
+          </a:fillRef>
+          <a:effectRef idx="2">
+            <a:schemeClr val="accent1"/>
+          </a:effectRef>
+          <a:fontRef idx="minor">
+            <a:schemeClr val="lt1"/>
+          </a:fontRef>
+        </p:style>
+        <p:txBody>
+          <a:bodyPr rtlCol="0" anchor="ctr" wrap="square" lIns="27432" rIns="27432" tIns="18288" bIns="18288"/>
+          <a:lstStyle/>
+          <a:p>
+            <a:pPr algn="ctr"/>
+            <a:r>
+              <a:rPr sz="1000">
+                <a:solidFill>
+                  <a:srgbClr val="202020"/>
+                </a:solidFill>
+                <a:latin typeface="Consolas"/>
+              </a:rPr>
+              <a:t>GenevaEMV3
+</a:t>
+            </a:r>
+            <a:r>
+              <a:rPr sz="1000">
+                <a:solidFill>
+                  <a:srgbClr val="202020"/>
+                </a:solidFill>
+                <a:latin typeface="Calibri"/>
+              </a:rPr>
+              <a:t>fixed rule module</a:t>
+            </a:r>
+          </a:p>
+        </p:txBody>
+      </p:sp>
+      <p:sp>
+        <p:nvSpPr>
+          <p:cNvPr id="9" name="Rounded Rectangle 8"/>
+          <p:cNvSpPr/>
+          <p:nvPr/>
+        </p:nvSpPr>
+        <p:spPr>
+          <a:xfrm>
+            <a:off x="8778240" y="1783080"/>
+            <a:ext cx="2651760" cy="566928"/>
+          </a:xfrm>
+          <a:prstGeom prst="roundRect">
+            <a:avLst>
+              <a:gd name="adj" fmla="val 10000"/>
+            </a:avLst>
+          </a:prstGeom>
+          <a:solidFill>
+            <a:srgbClr val="EEF4FA"/>
+          </a:solidFill>
+          <a:ln w="15240">
+            <a:solidFill>
+              <a:srgbClr val="2171B5"/>
+            </a:solidFill>
+          </a:ln>
+        </p:spPr>
+        <p:style>
+          <a:lnRef idx="1">
+            <a:schemeClr val="accent1"/>
+          </a:lnRef>
+          <a:fillRef idx="3">
+            <a:schemeClr val="accent1"/>
+          </a:fillRef>
+          <a:effectRef idx="2">
+            <a:schemeClr val="accent1"/>
+          </a:effectRef>
+          <a:fontRef idx="minor">
+            <a:schemeClr val="lt1"/>
+          </a:fontRef>
+        </p:style>
+        <p:txBody>
+          <a:bodyPr rtlCol="0" anchor="ctr" wrap="square" lIns="27432" rIns="27432" tIns="18288" bIns="18288"/>
+          <a:lstStyle/>
+          <a:p>
+            <a:pPr algn="ctr"/>
+            <a:r>
+              <a:rPr sz="1000">
+                <a:solidFill>
+                  <a:srgbClr val="202020"/>
+                </a:solidFill>
+                <a:latin typeface="Calibri"/>
+              </a:rPr>
+              <a:t>typed verdict
+</a:t>
+            </a:r>
+            <a:r>
+              <a:rPr sz="1000">
+                <a:solidFill>
+                  <a:srgbClr val="202020"/>
+                </a:solidFill>
+                <a:latin typeface="Consolas"/>
+              </a:rPr>
+              <a:t>forbid ⋯ strongly_prefer</a:t>
+            </a:r>
+          </a:p>
+        </p:txBody>
+      </p:sp>
+      <p:sp>
+        <p:nvSpPr>
+          <p:cNvPr id="10" name="Right Arrow 9"/>
+          <p:cNvSpPr/>
+          <p:nvPr/>
+        </p:nvSpPr>
+        <p:spPr>
+          <a:xfrm>
+            <a:off x="2724912" y="1993392"/>
+            <a:ext cx="402336" cy="146304"/>
+          </a:xfrm>
+          <a:prstGeom prst="rightArrow">
+            <a:avLst>
+              <a:gd name="adj1" fmla="val 55000"/>
+              <a:gd name="adj2" fmla="val 55000"/>
+            </a:avLst>
+          </a:prstGeom>
+          <a:solidFill>
+            <a:srgbClr val="636363"/>
+          </a:solidFill>
+          <a:ln>
+            <a:noFill/>
+          </a:ln>
+        </p:spPr>
+        <p:style>
+          <a:lnRef idx="1">
+            <a:schemeClr val="accent1"/>
+          </a:lnRef>
+          <a:fillRef idx="3">
+            <a:schemeClr val="accent1"/>
+          </a:fillRef>
+          <a:effectRef idx="2">
+            <a:schemeClr val="accent1"/>
+          </a:effectRef>
+          <a:fontRef idx="minor">
+            <a:schemeClr val="lt1"/>
+          </a:fontRef>
+        </p:style>
+        <p:txBody>
+          <a:bodyPr rtlCol="0" anchor="ctr"/>
+          <a:lstStyle/>
+          <a:p>
+            <a:pPr algn="ctr"/>
+          </a:p>
+        </p:txBody>
+      </p:sp>
+      <p:sp>
+        <p:nvSpPr>
+          <p:cNvPr id="11" name="Right Arrow 10"/>
+          <p:cNvSpPr/>
+          <p:nvPr/>
+        </p:nvSpPr>
+        <p:spPr>
+          <a:xfrm>
+            <a:off x="5376672" y="1993392"/>
+            <a:ext cx="402336" cy="146304"/>
+          </a:xfrm>
+          <a:prstGeom prst="rightArrow">
+            <a:avLst>
+              <a:gd name="adj1" fmla="val 55000"/>
+              <a:gd name="adj2" fmla="val 55000"/>
+            </a:avLst>
+          </a:prstGeom>
+          <a:solidFill>
+            <a:srgbClr val="636363"/>
+          </a:solidFill>
+          <a:ln>
+            <a:noFill/>
+          </a:ln>
+        </p:spPr>
+        <p:style>
+          <a:lnRef idx="1">
+            <a:schemeClr val="accent1"/>
+          </a:lnRef>
+          <a:fillRef idx="3">
+            <a:schemeClr val="accent1"/>
+          </a:fillRef>
+          <a:effectRef idx="2">
+            <a:schemeClr val="accent1"/>
+          </a:effectRef>
+          <a:fontRef idx="minor">
+            <a:schemeClr val="lt1"/>
+          </a:fontRef>
+        </p:style>
+        <p:txBody>
+          <a:bodyPr rtlCol="0" anchor="ctr"/>
+          <a:lstStyle/>
+          <a:p>
+            <a:pPr algn="ctr"/>
+          </a:p>
+        </p:txBody>
+      </p:sp>
+      <p:sp>
+        <p:nvSpPr>
+          <p:cNvPr id="12" name="Right Arrow 11"/>
+          <p:cNvSpPr/>
+          <p:nvPr/>
+        </p:nvSpPr>
+        <p:spPr>
+          <a:xfrm>
+            <a:off x="8257031" y="1993392"/>
+            <a:ext cx="402336" cy="146304"/>
+          </a:xfrm>
+          <a:prstGeom prst="rightArrow">
+            <a:avLst>
+              <a:gd name="adj1" fmla="val 55000"/>
+              <a:gd name="adj2" fmla="val 55000"/>
+            </a:avLst>
+          </a:prstGeom>
+          <a:solidFill>
+            <a:srgbClr val="636363"/>
+          </a:solidFill>
+          <a:ln>
+            <a:noFill/>
+          </a:ln>
+        </p:spPr>
+        <p:style>
+          <a:lnRef idx="1">
+            <a:schemeClr val="accent1"/>
+          </a:lnRef>
+          <a:fillRef idx="3">
+            <a:schemeClr val="accent1"/>
+          </a:fillRef>
+          <a:effectRef idx="2">
+            <a:schemeClr val="accent1"/>
+          </a:effectRef>
+          <a:fontRef idx="minor">
+            <a:schemeClr val="lt1"/>
+          </a:fontRef>
+        </p:style>
+        <p:txBody>
+          <a:bodyPr rtlCol="0" anchor="ctr"/>
+          <a:lstStyle/>
+          <a:p>
+            <a:pPr algn="ctr"/>
+          </a:p>
+        </p:txBody>
+      </p:sp>
+      <p:sp>
+        <p:nvSpPr>
+          <p:cNvPr id="13" name="Down Arrow 12"/>
+          <p:cNvSpPr/>
+          <p:nvPr/>
+        </p:nvSpPr>
+        <p:spPr>
+          <a:xfrm>
+            <a:off x="4133087" y="1243584"/>
+            <a:ext cx="146304" cy="457200"/>
+          </a:xfrm>
+          <a:prstGeom prst="downArrow">
+            <a:avLst>
+              <a:gd name="adj1" fmla="val 55000"/>
+              <a:gd name="adj2" fmla="val 55000"/>
+            </a:avLst>
+          </a:prstGeom>
+          <a:solidFill>
+            <a:srgbClr val="D95F02"/>
+          </a:solidFill>
+          <a:ln>
+            <a:noFill/>
+          </a:ln>
+        </p:spPr>
+        <p:style>
+          <a:lnRef idx="1">
+            <a:schemeClr val="accent1"/>
+          </a:lnRef>
+          <a:fillRef idx="3">
+            <a:schemeClr val="accent1"/>
+          </a:fillRef>
+          <a:effectRef idx="2">
+            <a:schemeClr val="accent1"/>
+          </a:effectRef>
+          <a:fontRef idx="minor">
+            <a:schemeClr val="lt1"/>
+          </a:fontRef>
+        </p:style>
+        <p:txBody>
+          <a:bodyPr rtlCol="0" anchor="ctr"/>
+          <a:lstStyle/>
+          <a:p>
+            <a:pPr algn="ctr"/>
+          </a:p>
+        </p:txBody>
+      </p:sp>
+      <p:sp>
+        <p:nvSpPr>
+          <p:cNvPr id="14" name="TextBox 13"/>
+          <p:cNvSpPr txBox="1"/>
+          <p:nvPr/>
+        </p:nvSpPr>
+        <p:spPr>
+          <a:xfrm>
+            <a:off x="4526280" y="1188720"/>
+            <a:ext cx="3291840" cy="457200"/>
+          </a:xfrm>
+          <a:prstGeom prst="rect">
+            <a:avLst/>
+          </a:prstGeom>
+          <a:noFill/>
+        </p:spPr>
+        <p:txBody>
+          <a:bodyPr wrap="square">
+            <a:spAutoFit/>
+          </a:bodyPr>
+          <a:lstStyle/>
+          <a:p>
+            <a:pPr algn="l">
+              <a:spcAft>
+                <a:spcPts val="600"/>
+              </a:spcAft>
+            </a:pPr>
+            <a:r>
+              <a:rPr sz="1100">
+                <a:solidFill>
+                  <a:srgbClr val="202020"/>
+                </a:solidFill>
+                <a:latin typeface="Calibri"/>
+              </a:rPr>
+              <a:t>euphemistic rewrite lands </a:t>
+            </a:r>
+            <a:r>
+              <a:rPr sz="1100" b="1">
+                <a:solidFill>
+                  <a:srgbClr val="D95F02"/>
+                </a:solidFill>
+                <a:latin typeface="Calibri"/>
+              </a:rPr>
+              <a:t>HERE</a:t>
+            </a:r>
+          </a:p>
+        </p:txBody>
+      </p:sp>
+      <p:sp>
+        <p:nvSpPr>
+          <p:cNvPr id="15" name="TextBox 14"/>
+          <p:cNvSpPr txBox="1"/>
+          <p:nvPr/>
+        </p:nvSpPr>
+        <p:spPr>
+          <a:xfrm>
+            <a:off x="5897880" y="2377440"/>
+            <a:ext cx="2286000" cy="274320"/>
+          </a:xfrm>
+          <a:prstGeom prst="rect">
+            <a:avLst/>
+          </a:prstGeom>
+          <a:noFill/>
+        </p:spPr>
+        <p:txBody>
+          <a:bodyPr wrap="square">
+            <a:spAutoFit/>
+          </a:bodyPr>
+          <a:lstStyle/>
           <a:p>
             <a:pPr algn="ctr">
               <a:spcAft>
@@ -11954,72 +14073,27 @@
               </a:spcAft>
             </a:pPr>
             <a:r>
-              <a:rPr sz="1400">
-                <a:solidFill>
-                  <a:srgbClr val="202020"/>
-                </a:solidFill>
-                <a:latin typeface="Calibri"/>
-              </a:rPr>
-              <a:t>text → </a:t>
-            </a:r>
-            <a:r>
-              <a:rPr sz="1400" b="1">
-                <a:solidFill>
-                  <a:srgbClr val="2171B5"/>
-                </a:solidFill>
-                <a:latin typeface="Calibri"/>
-              </a:rPr>
-              <a:t>LLM extracts ethical facts</a:t>
-            </a:r>
-            <a:r>
-              <a:rPr sz="1400">
-                <a:solidFill>
-                  <a:srgbClr val="202020"/>
-                </a:solidFill>
-                <a:latin typeface="Calibri"/>
-              </a:rPr>
-              <a:t> → </a:t>
-            </a:r>
-            <a:r>
-              <a:rPr sz="1400">
-                <a:solidFill>
-                  <a:srgbClr val="202020"/>
-                </a:solidFill>
-                <a:latin typeface="Consolas"/>
-              </a:rPr>
-              <a:t>GenevaEMV3</a:t>
-            </a:r>
-            <a:r>
-              <a:rPr sz="1400">
-                <a:solidFill>
-                  <a:srgbClr val="202020"/>
-                </a:solidFill>
-                <a:latin typeface="Calibri"/>
-              </a:rPr>
-              <a:t> → typed verdict   </a:t>
-            </a:r>
-            <a:r>
-              <a:rPr sz="1400">
-                <a:solidFill>
-                  <a:srgbClr val="202020"/>
-                </a:solidFill>
-                <a:latin typeface="Calibri"/>
-              </a:rPr>
-              <a:t>(forbid → avoid → neutral → prefer → strongly_prefer)</a:t>
-            </a:r>
-          </a:p>
-        </p:txBody>
-      </p:sp>
-      <p:sp>
-        <p:nvSpPr>
-          <p:cNvPr id="6" name="Rounded Rectangle 5"/>
+              <a:rPr sz="900">
+                <a:solidFill>
+                  <a:srgbClr val="636363"/>
+                </a:solidFill>
+                <a:latin typeface="Calibri"/>
+              </a:rPr>
+              <a:t>rules unchanged</a:t>
+            </a:r>
+          </a:p>
+        </p:txBody>
+      </p:sp>
+      <p:sp>
+        <p:nvSpPr>
+          <p:cNvPr id="16" name="Rounded Rectangle 15"/>
           <p:cNvSpPr/>
           <p:nvPr/>
         </p:nvSpPr>
         <p:spPr>
           <a:xfrm>
-            <a:off x="502920" y="2331720"/>
-            <a:ext cx="11155680" cy="2286000"/>
+            <a:off x="502920" y="2880360"/>
+            <a:ext cx="11155680" cy="2103120"/>
           </a:xfrm>
           <a:prstGeom prst="roundRect">
             <a:avLst>
@@ -12176,14 +14250,14 @@
       </p:sp>
       <p:sp>
         <p:nvSpPr>
-          <p:cNvPr id="7" name="TextBox 6"/>
+          <p:cNvPr id="17" name="TextBox 16"/>
           <p:cNvSpPr txBox="1"/>
           <p:nvPr/>
         </p:nvSpPr>
         <p:spPr>
           <a:xfrm>
-            <a:off x="502920" y="4983480"/>
-            <a:ext cx="11155680" cy="1097280"/>
+            <a:off x="502920" y="5212080"/>
+            <a:ext cx="11155680" cy="914400"/>
           </a:xfrm>
           <a:prstGeom prst="rect">
             <a:avLst/>
@@ -12382,8 +14456,8 @@
         </p:nvSpPr>
         <p:spPr>
           <a:xfrm>
-            <a:off x="502920" y="841248"/>
-            <a:ext cx="11155680" cy="4937760"/>
+            <a:off x="502920" y="822960"/>
+            <a:ext cx="11155680" cy="365760"/>
           </a:xfrm>
           <a:prstGeom prst="rect">
             <a:avLst/>
@@ -12398,11 +14472,11 @@
           <a:p>
             <a:pPr algn="l">
               <a:spcAft>
-                <a:spcPts val="800"/>
+                <a:spcPts val="600"/>
               </a:spcAft>
             </a:pPr>
             <a:r>
-              <a:rPr sz="1300">
+              <a:rPr sz="1200">
                 <a:solidFill>
                   <a:srgbClr val="636363"/>
                 </a:solidFill>
@@ -12411,7 +14485,7 @@
               <a:t>Second instantiation from here on: validated learned encoders (</a:t>
             </a:r>
             <a:r>
-              <a:rPr sz="1300">
+              <a:rPr sz="1200">
                 <a:solidFill>
                   <a:srgbClr val="636363"/>
                 </a:solidFill>
@@ -12420,7 +14494,7 @@
               <a:t>xbse</a:t>
             </a:r>
             <a:r>
-              <a:rPr sz="1300">
+              <a:rPr sz="1200">
                 <a:solidFill>
                   <a:srgbClr val="636363"/>
                 </a:solidFill>
@@ -12429,6 +14503,619 @@
               <a:t>) replace LLM judges; same DEME kernel.</a:t>
             </a:r>
           </a:p>
+        </p:txBody>
+      </p:sp>
+      <p:sp>
+        <p:nvSpPr>
+          <p:cNvPr id="6" name="Rounded Rectangle 5"/>
+          <p:cNvSpPr/>
+          <p:nvPr/>
+        </p:nvSpPr>
+        <p:spPr>
+          <a:xfrm>
+            <a:off x="640080" y="1417320"/>
+            <a:ext cx="1234440" cy="548640"/>
+          </a:xfrm>
+          <a:prstGeom prst="roundRect">
+            <a:avLst>
+              <a:gd name="adj" fmla="val 10000"/>
+            </a:avLst>
+          </a:prstGeom>
+          <a:solidFill>
+            <a:srgbClr val="EEF4FA"/>
+          </a:solidFill>
+          <a:ln w="15240">
+            <a:solidFill>
+              <a:srgbClr val="2171B5"/>
+            </a:solidFill>
+          </a:ln>
+        </p:spPr>
+        <p:style>
+          <a:lnRef idx="1">
+            <a:schemeClr val="accent1"/>
+          </a:lnRef>
+          <a:fillRef idx="3">
+            <a:schemeClr val="accent1"/>
+          </a:fillRef>
+          <a:effectRef idx="2">
+            <a:schemeClr val="accent1"/>
+          </a:effectRef>
+          <a:fontRef idx="minor">
+            <a:schemeClr val="lt1"/>
+          </a:fontRef>
+        </p:style>
+        <p:txBody>
+          <a:bodyPr rtlCol="0" anchor="ctr" wrap="square" lIns="27432" rIns="27432" tIns="18288" bIns="18288"/>
+          <a:lstStyle/>
+          <a:p>
+            <a:pPr algn="ctr"/>
+            <a:r>
+              <a:rPr sz="1100">
+                <a:solidFill>
+                  <a:srgbClr val="202020"/>
+                </a:solidFill>
+                <a:latin typeface="Calibri"/>
+              </a:rPr>
+              <a:t>input x</a:t>
+            </a:r>
+          </a:p>
+        </p:txBody>
+      </p:sp>
+      <p:sp>
+        <p:nvSpPr>
+          <p:cNvPr id="7" name="Rounded Rectangle 6"/>
+          <p:cNvSpPr/>
+          <p:nvPr/>
+        </p:nvSpPr>
+        <p:spPr>
+          <a:xfrm>
+            <a:off x="2377440" y="1417320"/>
+            <a:ext cx="2331720" cy="548640"/>
+          </a:xfrm>
+          <a:prstGeom prst="roundRect">
+            <a:avLst>
+              <a:gd name="adj" fmla="val 10000"/>
+            </a:avLst>
+          </a:prstGeom>
+          <a:solidFill>
+            <a:srgbClr val="FCF1E8"/>
+          </a:solidFill>
+          <a:ln w="15240">
+            <a:solidFill>
+              <a:srgbClr val="D95F02"/>
+            </a:solidFill>
+            <a:prstDash val="dash"/>
+          </a:ln>
+        </p:spPr>
+        <p:style>
+          <a:lnRef idx="1">
+            <a:schemeClr val="accent1"/>
+          </a:lnRef>
+          <a:fillRef idx="3">
+            <a:schemeClr val="accent1"/>
+          </a:fillRef>
+          <a:effectRef idx="2">
+            <a:schemeClr val="accent1"/>
+          </a:effectRef>
+          <a:fontRef idx="minor">
+            <a:schemeClr val="lt1"/>
+          </a:fontRef>
+        </p:style>
+        <p:txBody>
+          <a:bodyPr rtlCol="0" anchor="ctr" wrap="square" lIns="27432" rIns="27432" tIns="18288" bIns="18288"/>
+          <a:lstStyle/>
+          <a:p>
+            <a:pPr algn="ctr"/>
+            <a:r>
+              <a:rPr sz="1000">
+                <a:solidFill>
+                  <a:srgbClr val="202020"/>
+                </a:solidFill>
+                <a:latin typeface="Calibri"/>
+              </a:rPr>
+              <a:t>paraphrase class
+</a:t>
+            </a:r>
+            <a:r>
+              <a:rPr sz="1000">
+                <a:solidFill>
+                  <a:srgbClr val="202020"/>
+                </a:solidFill>
+                <a:latin typeface="Calibri"/>
+              </a:rPr>
+              <a:t>x₁ ⋯ xₘ (generated)</a:t>
+            </a:r>
+          </a:p>
+        </p:txBody>
+      </p:sp>
+      <p:sp>
+        <p:nvSpPr>
+          <p:cNvPr id="8" name="Rounded Rectangle 7"/>
+          <p:cNvSpPr/>
+          <p:nvPr/>
+        </p:nvSpPr>
+        <p:spPr>
+          <a:xfrm>
+            <a:off x="5212080" y="1417320"/>
+            <a:ext cx="1783080" cy="548640"/>
+          </a:xfrm>
+          <a:prstGeom prst="roundRect">
+            <a:avLst>
+              <a:gd name="adj" fmla="val 10000"/>
+            </a:avLst>
+          </a:prstGeom>
+          <a:solidFill>
+            <a:srgbClr val="EEF4FA"/>
+          </a:solidFill>
+          <a:ln w="15240">
+            <a:solidFill>
+              <a:srgbClr val="2171B5"/>
+            </a:solidFill>
+          </a:ln>
+        </p:spPr>
+        <p:style>
+          <a:lnRef idx="1">
+            <a:schemeClr val="accent1"/>
+          </a:lnRef>
+          <a:fillRef idx="3">
+            <a:schemeClr val="accent1"/>
+          </a:fillRef>
+          <a:effectRef idx="2">
+            <a:schemeClr val="accent1"/>
+          </a:effectRef>
+          <a:fontRef idx="minor">
+            <a:schemeClr val="lt1"/>
+          </a:fontRef>
+        </p:style>
+        <p:txBody>
+          <a:bodyPr rtlCol="0" anchor="ctr" wrap="square" lIns="27432" rIns="27432" tIns="18288" bIns="18288"/>
+          <a:lstStyle/>
+          <a:p>
+            <a:pPr algn="ctr"/>
+            <a:r>
+              <a:rPr sz="1100">
+                <a:solidFill>
+                  <a:srgbClr val="202020"/>
+                </a:solidFill>
+                <a:latin typeface="Calibri"/>
+              </a:rPr>
+              <a:t>validated encoders</a:t>
+            </a:r>
+          </a:p>
+        </p:txBody>
+      </p:sp>
+      <p:sp>
+        <p:nvSpPr>
+          <p:cNvPr id="9" name="Rounded Rectangle 8"/>
+          <p:cNvSpPr/>
+          <p:nvPr/>
+        </p:nvSpPr>
+        <p:spPr>
+          <a:xfrm>
+            <a:off x="7498079" y="1417320"/>
+            <a:ext cx="1920240" cy="548640"/>
+          </a:xfrm>
+          <a:prstGeom prst="roundRect">
+            <a:avLst>
+              <a:gd name="adj" fmla="val 10000"/>
+            </a:avLst>
+          </a:prstGeom>
+          <a:solidFill>
+            <a:srgbClr val="E9F5F1"/>
+          </a:solidFill>
+          <a:ln w="15240">
+            <a:solidFill>
+              <a:srgbClr val="1B9E77"/>
+            </a:solidFill>
+          </a:ln>
+        </p:spPr>
+        <p:style>
+          <a:lnRef idx="1">
+            <a:schemeClr val="accent1"/>
+          </a:lnRef>
+          <a:fillRef idx="3">
+            <a:schemeClr val="accent1"/>
+          </a:fillRef>
+          <a:effectRef idx="2">
+            <a:schemeClr val="accent1"/>
+          </a:effectRef>
+          <a:fontRef idx="minor">
+            <a:schemeClr val="lt1"/>
+          </a:fontRef>
+        </p:style>
+        <p:txBody>
+          <a:bodyPr rtlCol="0" anchor="ctr" wrap="square" lIns="27432" rIns="27432" tIns="18288" bIns="18288"/>
+          <a:lstStyle/>
+          <a:p>
+            <a:pPr algn="ctr"/>
+            <a:r>
+              <a:rPr sz="1000" b="1">
+                <a:solidFill>
+                  <a:srgbClr val="202020"/>
+                </a:solidFill>
+                <a:latin typeface="Calibri"/>
+              </a:rPr>
+              <a:t>average
+</a:t>
+            </a:r>
+            <a:r>
+              <a:rPr sz="1000">
+                <a:solidFill>
+                  <a:srgbClr val="202020"/>
+                </a:solidFill>
+                <a:latin typeface="Calibri"/>
+              </a:rPr>
+              <a:t>over the class</a:t>
+            </a:r>
+          </a:p>
+        </p:txBody>
+      </p:sp>
+      <p:sp>
+        <p:nvSpPr>
+          <p:cNvPr id="10" name="Rounded Rectangle 9"/>
+          <p:cNvSpPr/>
+          <p:nvPr/>
+        </p:nvSpPr>
+        <p:spPr>
+          <a:xfrm>
+            <a:off x="9921240" y="1417320"/>
+            <a:ext cx="1280160" cy="548640"/>
+          </a:xfrm>
+          <a:prstGeom prst="roundRect">
+            <a:avLst>
+              <a:gd name="adj" fmla="val 10000"/>
+            </a:avLst>
+          </a:prstGeom>
+          <a:solidFill>
+            <a:srgbClr val="EEF4FA"/>
+          </a:solidFill>
+          <a:ln w="15240">
+            <a:solidFill>
+              <a:srgbClr val="2171B5"/>
+            </a:solidFill>
+          </a:ln>
+        </p:spPr>
+        <p:style>
+          <a:lnRef idx="1">
+            <a:schemeClr val="accent1"/>
+          </a:lnRef>
+          <a:fillRef idx="3">
+            <a:schemeClr val="accent1"/>
+          </a:fillRef>
+          <a:effectRef idx="2">
+            <a:schemeClr val="accent1"/>
+          </a:effectRef>
+          <a:fontRef idx="minor">
+            <a:schemeClr val="lt1"/>
+          </a:fontRef>
+        </p:style>
+        <p:txBody>
+          <a:bodyPr rtlCol="0" anchor="ctr" wrap="square" lIns="27432" rIns="27432" tIns="18288" bIns="18288"/>
+          <a:lstStyle/>
+          <a:p>
+            <a:pPr algn="ctr"/>
+            <a:r>
+              <a:rPr sz="1100">
+                <a:solidFill>
+                  <a:srgbClr val="202020"/>
+                </a:solidFill>
+                <a:latin typeface="Calibri"/>
+              </a:rPr>
+              <a:t>decide</a:t>
+            </a:r>
+          </a:p>
+        </p:txBody>
+      </p:sp>
+      <p:sp>
+        <p:nvSpPr>
+          <p:cNvPr id="11" name="Right Arrow 10"/>
+          <p:cNvSpPr/>
+          <p:nvPr/>
+        </p:nvSpPr>
+        <p:spPr>
+          <a:xfrm>
+            <a:off x="1920240" y="1618488"/>
+            <a:ext cx="402336" cy="146304"/>
+          </a:xfrm>
+          <a:prstGeom prst="rightArrow">
+            <a:avLst>
+              <a:gd name="adj1" fmla="val 55000"/>
+              <a:gd name="adj2" fmla="val 55000"/>
+            </a:avLst>
+          </a:prstGeom>
+          <a:solidFill>
+            <a:srgbClr val="636363"/>
+          </a:solidFill>
+          <a:ln>
+            <a:noFill/>
+          </a:ln>
+        </p:spPr>
+        <p:style>
+          <a:lnRef idx="1">
+            <a:schemeClr val="accent1"/>
+          </a:lnRef>
+          <a:fillRef idx="3">
+            <a:schemeClr val="accent1"/>
+          </a:fillRef>
+          <a:effectRef idx="2">
+            <a:schemeClr val="accent1"/>
+          </a:effectRef>
+          <a:fontRef idx="minor">
+            <a:schemeClr val="lt1"/>
+          </a:fontRef>
+        </p:style>
+        <p:txBody>
+          <a:bodyPr rtlCol="0" anchor="ctr"/>
+          <a:lstStyle/>
+          <a:p>
+            <a:pPr algn="ctr"/>
+          </a:p>
+        </p:txBody>
+      </p:sp>
+      <p:sp>
+        <p:nvSpPr>
+          <p:cNvPr id="12" name="Right Arrow 11"/>
+          <p:cNvSpPr/>
+          <p:nvPr/>
+        </p:nvSpPr>
+        <p:spPr>
+          <a:xfrm>
+            <a:off x="4754880" y="1618488"/>
+            <a:ext cx="402336" cy="146304"/>
+          </a:xfrm>
+          <a:prstGeom prst="rightArrow">
+            <a:avLst>
+              <a:gd name="adj1" fmla="val 55000"/>
+              <a:gd name="adj2" fmla="val 55000"/>
+            </a:avLst>
+          </a:prstGeom>
+          <a:solidFill>
+            <a:srgbClr val="636363"/>
+          </a:solidFill>
+          <a:ln>
+            <a:noFill/>
+          </a:ln>
+        </p:spPr>
+        <p:style>
+          <a:lnRef idx="1">
+            <a:schemeClr val="accent1"/>
+          </a:lnRef>
+          <a:fillRef idx="3">
+            <a:schemeClr val="accent1"/>
+          </a:fillRef>
+          <a:effectRef idx="2">
+            <a:schemeClr val="accent1"/>
+          </a:effectRef>
+          <a:fontRef idx="minor">
+            <a:schemeClr val="lt1"/>
+          </a:fontRef>
+        </p:style>
+        <p:txBody>
+          <a:bodyPr rtlCol="0" anchor="ctr"/>
+          <a:lstStyle/>
+          <a:p>
+            <a:pPr algn="ctr"/>
+          </a:p>
+        </p:txBody>
+      </p:sp>
+      <p:sp>
+        <p:nvSpPr>
+          <p:cNvPr id="13" name="Right Arrow 12"/>
+          <p:cNvSpPr/>
+          <p:nvPr/>
+        </p:nvSpPr>
+        <p:spPr>
+          <a:xfrm>
+            <a:off x="7040880" y="1618488"/>
+            <a:ext cx="402336" cy="146304"/>
+          </a:xfrm>
+          <a:prstGeom prst="rightArrow">
+            <a:avLst>
+              <a:gd name="adj1" fmla="val 55000"/>
+              <a:gd name="adj2" fmla="val 55000"/>
+            </a:avLst>
+          </a:prstGeom>
+          <a:solidFill>
+            <a:srgbClr val="636363"/>
+          </a:solidFill>
+          <a:ln>
+            <a:noFill/>
+          </a:ln>
+        </p:spPr>
+        <p:style>
+          <a:lnRef idx="1">
+            <a:schemeClr val="accent1"/>
+          </a:lnRef>
+          <a:fillRef idx="3">
+            <a:schemeClr val="accent1"/>
+          </a:fillRef>
+          <a:effectRef idx="2">
+            <a:schemeClr val="accent1"/>
+          </a:effectRef>
+          <a:fontRef idx="minor">
+            <a:schemeClr val="lt1"/>
+          </a:fontRef>
+        </p:style>
+        <p:txBody>
+          <a:bodyPr rtlCol="0" anchor="ctr"/>
+          <a:lstStyle/>
+          <a:p>
+            <a:pPr algn="ctr"/>
+          </a:p>
+        </p:txBody>
+      </p:sp>
+      <p:sp>
+        <p:nvSpPr>
+          <p:cNvPr id="14" name="Right Arrow 13"/>
+          <p:cNvSpPr/>
+          <p:nvPr/>
+        </p:nvSpPr>
+        <p:spPr>
+          <a:xfrm>
+            <a:off x="9464040" y="1618488"/>
+            <a:ext cx="402336" cy="146304"/>
+          </a:xfrm>
+          <a:prstGeom prst="rightArrow">
+            <a:avLst>
+              <a:gd name="adj1" fmla="val 55000"/>
+              <a:gd name="adj2" fmla="val 55000"/>
+            </a:avLst>
+          </a:prstGeom>
+          <a:solidFill>
+            <a:srgbClr val="636363"/>
+          </a:solidFill>
+          <a:ln>
+            <a:noFill/>
+          </a:ln>
+        </p:spPr>
+        <p:style>
+          <a:lnRef idx="1">
+            <a:schemeClr val="accent1"/>
+          </a:lnRef>
+          <a:fillRef idx="3">
+            <a:schemeClr val="accent1"/>
+          </a:fillRef>
+          <a:effectRef idx="2">
+            <a:schemeClr val="accent1"/>
+          </a:effectRef>
+          <a:fontRef idx="minor">
+            <a:schemeClr val="lt1"/>
+          </a:fontRef>
+        </p:style>
+        <p:txBody>
+          <a:bodyPr rtlCol="0" anchor="ctr"/>
+          <a:lstStyle/>
+          <a:p>
+            <a:pPr algn="ctr"/>
+          </a:p>
+        </p:txBody>
+      </p:sp>
+      <p:sp>
+        <p:nvSpPr>
+          <p:cNvPr id="15" name="TextBox 14"/>
+          <p:cNvSpPr txBox="1"/>
+          <p:nvPr/>
+        </p:nvSpPr>
+        <p:spPr>
+          <a:xfrm>
+            <a:off x="1965960" y="2029968"/>
+            <a:ext cx="3291840" cy="548640"/>
+          </a:xfrm>
+          <a:prstGeom prst="rect">
+            <a:avLst/>
+          </a:prstGeom>
+          <a:noFill/>
+        </p:spPr>
+        <p:txBody>
+          <a:bodyPr wrap="square">
+            <a:spAutoFit/>
+          </a:bodyPr>
+          <a:lstStyle/>
+          <a:p>
+            <a:pPr algn="ctr">
+              <a:spcAft>
+                <a:spcPts val="600"/>
+              </a:spcAft>
+            </a:pPr>
+            <a:r>
+              <a:rPr sz="900">
+                <a:solidFill>
+                  <a:srgbClr val="D95F02"/>
+                </a:solidFill>
+                <a:latin typeface="Calibri"/>
+              </a:rPr>
+              <a:t>the measured hole: a euphemistic x yields a class that </a:t>
+            </a:r>
+            <a:r>
+              <a:rPr sz="900" i="1">
+                <a:solidFill>
+                  <a:srgbClr val="D95F02"/>
+                </a:solidFill>
+                <a:latin typeface="Calibri"/>
+              </a:rPr>
+              <a:t>stays</a:t>
+            </a:r>
+            <a:r>
+              <a:rPr sz="900">
+                <a:solidFill>
+                  <a:srgbClr val="D95F02"/>
+                </a:solidFill>
+                <a:latin typeface="Calibri"/>
+              </a:rPr>
+              <a:t> euphemistic</a:t>
+            </a:r>
+          </a:p>
+        </p:txBody>
+      </p:sp>
+      <p:sp>
+        <p:nvSpPr>
+          <p:cNvPr id="16" name="TextBox 15"/>
+          <p:cNvSpPr txBox="1"/>
+          <p:nvPr/>
+        </p:nvSpPr>
+        <p:spPr>
+          <a:xfrm>
+            <a:off x="9281160" y="2029968"/>
+            <a:ext cx="2560320" cy="548640"/>
+          </a:xfrm>
+          <a:prstGeom prst="rect">
+            <a:avLst/>
+          </a:prstGeom>
+          <a:noFill/>
+        </p:spPr>
+        <p:txBody>
+          <a:bodyPr wrap="square">
+            <a:spAutoFit/>
+          </a:bodyPr>
+          <a:lstStyle/>
+          <a:p>
+            <a:pPr algn="ctr">
+              <a:spcAft>
+                <a:spcPts val="600"/>
+              </a:spcAft>
+            </a:pPr>
+            <a:r>
+              <a:rPr sz="900">
+                <a:solidFill>
+                  <a:srgbClr val="636363"/>
+                </a:solidFill>
+                <a:latin typeface="Calibri"/>
+              </a:rPr>
+              <a:t>refusal → singleton → </a:t>
+            </a:r>
+            <a:r>
+              <a:rPr sz="900" b="1">
+                <a:solidFill>
+                  <a:srgbClr val="636363"/>
+                </a:solidFill>
+                <a:latin typeface="Calibri"/>
+              </a:rPr>
+              <a:t>escalate</a:t>
+            </a:r>
+          </a:p>
+        </p:txBody>
+      </p:sp>
+      <p:sp>
+        <p:nvSpPr>
+          <p:cNvPr id="17" name="TextBox 16"/>
+          <p:cNvSpPr txBox="1"/>
+          <p:nvPr/>
+        </p:nvSpPr>
+        <p:spPr>
+          <a:xfrm>
+            <a:off x="502920" y="2697480"/>
+            <a:ext cx="11155680" cy="2743200"/>
+          </a:xfrm>
+          <a:prstGeom prst="rect">
+            <a:avLst/>
+          </a:prstGeom>
+          <a:noFill/>
+        </p:spPr>
+        <p:txBody>
+          <a:bodyPr wrap="square">
+            <a:spAutoFit/>
+          </a:bodyPr>
+          <a:lstStyle/>
           <a:p>
             <a:pPr algn="l">
               <a:spcAft>
@@ -12436,198 +15123,76 @@
               </a:spcAft>
             </a:pPr>
             <a:r>
-              <a:rPr sz="1600" b="1">
-                <a:solidFill>
-                  <a:srgbClr val="202020"/>
-                </a:solidFill>
-                <a:latin typeface="Calibri"/>
-              </a:rPr>
-              <a:t>Equivalence-class averaging</a:t>
-            </a:r>
-            <a:r>
-              <a:rPr sz="1600">
-                <a:solidFill>
-                  <a:srgbClr val="202020"/>
-                </a:solidFill>
-                <a:latin typeface="Calibri"/>
-              </a:rPr>
-              <a:t>: generate the input's paraphrase class (m paraphrases), </a:t>
-            </a:r>
-            <a:r>
-              <a:rPr sz="1600" b="1">
+              <a:rPr sz="1500" b="1">
                 <a:solidFill>
                   <a:srgbClr val="2171B5"/>
                 </a:solidFill>
                 <a:latin typeface="Calibri"/>
               </a:rPr>
-              <a:t>average per-dimension perception over the class</a:t>
-            </a:r>
-            <a:r>
-              <a:rPr sz="1600">
-                <a:solidFill>
-                  <a:srgbClr val="202020"/>
-                </a:solidFill>
-                <a:latin typeface="Calibri"/>
-              </a:rPr>
-              <a:t>, then decide.</a:t>
-            </a:r>
-          </a:p>
-          <a:p>
-            <a:pPr algn="l">
-              <a:spcAft>
-                <a:spcPts val="1000"/>
-              </a:spcAft>
-            </a:pPr>
-            <a:r>
-              <a:rPr sz="1600" b="1">
+              <a:t>▪  </a:t>
+            </a:r>
+            <a:r>
+              <a:rPr sz="1500">
+                <a:solidFill>
+                  <a:srgbClr val="202020"/>
+                </a:solidFill>
+                <a:latin typeface="Calibri"/>
+              </a:rPr>
+              <a:t>At scale (60 held-out items, m = 6): raw drift </a:t>
+            </a:r>
+            <a:r>
+              <a:rPr sz="1500" b="1">
+                <a:solidFill>
+                  <a:srgbClr val="D95F02"/>
+                </a:solidFill>
+                <a:latin typeface="Calibri"/>
+              </a:rPr>
+              <a:t>0.407 → θₔ = 0.219</a:t>
+            </a:r>
+            <a:r>
+              <a:rPr sz="1500">
+                <a:solidFill>
+                  <a:srgbClr val="202020"/>
+                </a:solidFill>
+                <a:latin typeface="Calibri"/>
+              </a:rPr>
+              <a:t> — the mechanism </a:t>
+            </a:r>
+            <a:r>
+              <a:rPr sz="1500" b="1">
                 <a:solidFill>
                   <a:srgbClr val="2171B5"/>
                 </a:solidFill>
                 <a:latin typeface="Calibri"/>
               </a:rPr>
-              <a:t>▪  </a:t>
-            </a:r>
-            <a:r>
-              <a:rPr sz="1600">
-                <a:solidFill>
-                  <a:srgbClr val="202020"/>
-                </a:solidFill>
-                <a:latin typeface="Calibri"/>
-              </a:rPr>
-              <a:t>At scale (60 held-out items, m = 6): raw drift </a:t>
-            </a:r>
-            <a:r>
-              <a:rPr sz="1600" b="1">
-                <a:solidFill>
-                  <a:srgbClr val="D95F02"/>
-                </a:solidFill>
-                <a:latin typeface="Calibri"/>
-              </a:rPr>
-              <a:t>0.407 → θₔ = 0.219</a:t>
-            </a:r>
-            <a:r>
-              <a:rPr sz="1600">
-                <a:solidFill>
-                  <a:srgbClr val="202020"/>
-                </a:solidFill>
-                <a:latin typeface="Calibri"/>
-              </a:rPr>
-              <a:t> — the mechanism </a:t>
-            </a:r>
-            <a:r>
-              <a:rPr sz="1600" b="1">
+              <a:t>halves</a:t>
+            </a:r>
+            <a:r>
+              <a:rPr sz="1500">
+                <a:solidFill>
+                  <a:srgbClr val="202020"/>
+                </a:solidFill>
+                <a:latin typeface="Calibri"/>
+              </a:rPr>
+              <a:t> salience drift (θₔ: mean per-dimension decision movement). The registered bar θₔ ≤ 0.5 </a:t>
+            </a:r>
+            <a:r>
+              <a:rPr sz="1500" b="1">
                 <a:solidFill>
                   <a:srgbClr val="2171B5"/>
                 </a:solidFill>
                 <a:latin typeface="Calibri"/>
               </a:rPr>
-              <a:t>halves</a:t>
-            </a:r>
-            <a:r>
-              <a:rPr sz="1600">
-                <a:solidFill>
-                  <a:srgbClr val="202020"/>
-                </a:solidFill>
-                <a:latin typeface="Calibri"/>
-              </a:rPr>
-              <a:t> salience drift (θₔ: mean per-dimension decision movement). The registered bar θₔ ≤ 0.5 </a:t>
-            </a:r>
-            <a:r>
-              <a:rPr sz="1600" b="1">
-                <a:solidFill>
-                  <a:srgbClr val="2171B5"/>
-                </a:solidFill>
-                <a:latin typeface="Calibri"/>
-              </a:rPr>
               <a:t>binds for adversarial-register inputs</a:t>
             </a:r>
             <a:r>
-              <a:rPr sz="1600">
+              <a:rPr sz="1500">
                 <a:solidFill>
                   <a:srgbClr val="202020"/>
                 </a:solidFill>
                 <a:latin typeface="Calibri"/>
               </a:rPr>
               <a:t> (raw 0.67–0.85); the defended run there is the registered open item.</a:t>
-            </a:r>
-          </a:p>
-          <a:p>
-            <a:pPr algn="l">
-              <a:spcAft>
-                <a:spcPts val="1000"/>
-              </a:spcAft>
-            </a:pPr>
-            <a:r>
-              <a:rPr sz="1600" b="1">
-                <a:solidFill>
-                  <a:srgbClr val="2171B5"/>
-                </a:solidFill>
-                <a:latin typeface="Calibri"/>
-              </a:rPr>
-              <a:t>▪  </a:t>
-            </a:r>
-            <a:r>
-              <a:rPr sz="1600">
-                <a:solidFill>
-                  <a:srgbClr val="202020"/>
-                </a:solidFill>
-                <a:latin typeface="Calibri"/>
-              </a:rPr>
-              <a:t>LLM paraphrasers </a:t>
-            </a:r>
-            <a:r>
-              <a:rPr sz="1600" b="1">
-                <a:solidFill>
-                  <a:srgbClr val="D95F02"/>
-                </a:solidFill>
-                <a:latin typeface="Calibri"/>
-              </a:rPr>
-              <a:t>refuse 24%</a:t>
-            </a:r>
-            <a:r>
-              <a:rPr sz="1600">
-                <a:solidFill>
-                  <a:srgbClr val="202020"/>
-                </a:solidFill>
-                <a:latin typeface="Calibri"/>
-              </a:rPr>
-              <a:t> of harmful inputs. A non-refusing red-team paraphraser (NLLB back-translation, 6 pivots): </a:t>
-            </a:r>
-            <a:r>
-              <a:rPr sz="1600" b="1">
-                <a:solidFill>
-                  <a:srgbClr val="D95F02"/>
-                </a:solidFill>
-                <a:latin typeface="Calibri"/>
-              </a:rPr>
-              <a:t>θₔ = 0.301</a:t>
-            </a:r>
-            <a:r>
-              <a:rPr sz="1600">
-                <a:solidFill>
-                  <a:srgbClr val="202020"/>
-                </a:solidFill>
-                <a:latin typeface="Calibri"/>
-              </a:rPr>
-              <a:t> on harmful content — the weakness is the </a:t>
-            </a:r>
-            <a:r>
-              <a:rPr sz="1600" b="1">
-                <a:solidFill>
-                  <a:srgbClr val="2171B5"/>
-                </a:solidFill>
-                <a:latin typeface="Calibri"/>
-              </a:rPr>
-              <a:t>generator's</a:t>
-            </a:r>
-            <a:r>
-              <a:rPr sz="1600">
-                <a:solidFill>
-                  <a:srgbClr val="202020"/>
-                </a:solidFill>
-                <a:latin typeface="Calibri"/>
-              </a:rPr>
-              <a:t>, not the mechanism's.</a:t>
             </a:r>
           </a:p>
           <a:p>
@@ -12637,7 +15202,7 @@
               </a:spcAft>
             </a:pPr>
             <a:r>
-              <a:rPr sz="1600" b="1">
+              <a:rPr sz="1500" b="1">
                 <a:solidFill>
                   <a:srgbClr val="2171B5"/>
                 </a:solidFill>
@@ -12646,38 +15211,74 @@
               <a:t>▪  </a:t>
             </a:r>
             <a:r>
-              <a:rPr sz="1600">
-                <a:solidFill>
-                  <a:srgbClr val="202020"/>
-                </a:solidFill>
-                <a:latin typeface="Calibri"/>
-              </a:rPr>
-              <a:t>Trust boundary: refusal → singleton class → </a:t>
-            </a:r>
-            <a:r>
-              <a:rPr sz="1600" b="1">
+              <a:rPr sz="1500">
+                <a:solidFill>
+                  <a:srgbClr val="202020"/>
+                </a:solidFill>
+                <a:latin typeface="Calibri"/>
+              </a:rPr>
+              <a:t>LLM paraphrasers </a:t>
+            </a:r>
+            <a:r>
+              <a:rPr sz="1500" b="1">
+                <a:solidFill>
+                  <a:srgbClr val="D95F02"/>
+                </a:solidFill>
+                <a:latin typeface="Calibri"/>
+              </a:rPr>
+              <a:t>refuse 24%</a:t>
+            </a:r>
+            <a:r>
+              <a:rPr sz="1500">
+                <a:solidFill>
+                  <a:srgbClr val="202020"/>
+                </a:solidFill>
+                <a:latin typeface="Calibri"/>
+              </a:rPr>
+              <a:t> of harmful inputs. A non-refusing red-team paraphraser (NLLB back-translation, 6 pivots): </a:t>
+            </a:r>
+            <a:r>
+              <a:rPr sz="1500" b="1">
+                <a:solidFill>
+                  <a:srgbClr val="D95F02"/>
+                </a:solidFill>
+                <a:latin typeface="Calibri"/>
+              </a:rPr>
+              <a:t>θₔ = 0.301</a:t>
+            </a:r>
+            <a:r>
+              <a:rPr sz="1500">
+                <a:solidFill>
+                  <a:srgbClr val="202020"/>
+                </a:solidFill>
+                <a:latin typeface="Calibri"/>
+              </a:rPr>
+              <a:t> on harmful content — the weakness is the </a:t>
+            </a:r>
+            <a:r>
+              <a:rPr sz="1500" b="1">
                 <a:solidFill>
                   <a:srgbClr val="2171B5"/>
                 </a:solidFill>
                 <a:latin typeface="Calibri"/>
               </a:rPr>
-              <a:t>escalate by default</a:t>
-            </a:r>
-            <a:r>
-              <a:rPr sz="1600">
-                <a:solidFill>
-                  <a:srgbClr val="202020"/>
-                </a:solidFill>
-                <a:latin typeface="Calibri"/>
-              </a:rPr>
-              <a:t>; the audit proof records class members.</a:t>
-            </a:r>
-          </a:p>
-        </p:txBody>
-      </p:sp>
-      <p:sp>
-        <p:nvSpPr>
-          <p:cNvPr id="6" name="TextBox 5"/>
+              <a:t>generator's</a:t>
+            </a:r>
+            <a:r>
+              <a:rPr sz="1500">
+                <a:solidFill>
+                  <a:srgbClr val="202020"/>
+                </a:solidFill>
+                <a:latin typeface="Calibri"/>
+              </a:rPr>
+              <a:t>, not the mechanism's.</a:t>
+            </a:r>
+          </a:p>
+        </p:txBody>
+      </p:sp>
+      <p:sp>
+        <p:nvSpPr>
+          <p:cNvPr id="18" name="TextBox 17"/>
           <p:cNvSpPr txBox="1"/>
           <p:nvPr/>
         </p:nvSpPr>

</xml_diff>